<commit_message>
correcting data and adding content to presentation
</commit_message>
<xml_diff>
--- a/presentation/defense.pptx
+++ b/presentation/defense.pptx
@@ -153,7 +153,7 @@
     </p:spTree>
     <p:extLst>
       <p:ext uri="{BB962C8B-B14F-4D97-AF65-F5344CB8AC3E}">
-        <p14:creationId xmlns:p14="http://schemas.microsoft.com/office/powerpoint/2010/main" val="3608353361"/>
+        <p14:creationId xmlns:p14="http://schemas.microsoft.com/office/powerpoint/2010/main" val="2476988986"/>
       </p:ext>
     </p:extLst>
   </p:cSld>
@@ -473,7 +473,7 @@
           <a:p>
             <a:r>
               <a:rPr lang="en-US" dirty="0"/>
-              <a:t>10:00-11:15. The distinctive finding. The 2024 equal-weight top rank is a photo-finish: classic TOPSIS puts SVC-04 first by 0.004; SAW, VIKOR and the absolute variant put SVC-01 first, because regret capping and fixed anchors register SVC-01's worst patch recency and 4,054 unsupported months at full strength while vector normalisation is dominated by SVC-04's incident mass. In 2025 and under 2024 adjusted weights everything agrees on SVC-01.</a:t>
+              <a:t>10:00-11:15. The 2024 equal-weight top rank is a photo-finish: classic TOPSIS puts SVC-04 first by 0.004; SAW, VIKOR and the absolute variant put SVC-01 first. Both services are worst on exactly two criteria; SVC-04 is perfect on its other two while SVC-01 is only good, so linear aggregation favours SVC-01 while vector normalisation, which preserves SVC-04's outlying incident count, does not. If pressed: VIKOR's utility term is algebraically 1 minus SAW, so those two are not fully independent; VIKOR adds information only through regret. In 2025 everything agrees on SVC-01.</a:t>
             </a:r>
           </a:p>
         </p:txBody>
@@ -2582,7 +2582,7 @@
               <a:buNone/>
             </a:pPr>
             <a:r>
-              <a:rPr lang="en-US" sz="1700" b="1" dirty="0">
+              <a:rPr lang="en-US" sz="1600" b="1" dirty="0">
                 <a:solidFill>
                   <a:srgbClr val="D98E1F"/>
                 </a:solidFill>
@@ -2592,7 +2592,7 @@
               </a:rPr>
               <a:t>SVC-01 rises, fourth to first</a:t>
             </a:r>
-            <a:endParaRPr lang="en-US" sz="1700" dirty="0"/>
+            <a:endParaRPr lang="en-US" sz="1600" dirty="0"/>
           </a:p>
         </p:txBody>
       </p:sp>
@@ -2624,7 +2624,7 @@
               <a:buNone/>
             </a:pPr>
             <a:r>
-              <a:rPr lang="en-US" sz="1300" dirty="0">
+              <a:rPr lang="en-US" sz="1400" dirty="0">
                 <a:solidFill>
                   <a:srgbClr val="2A3F55"/>
                 </a:solidFill>
@@ -2634,7 +2634,7 @@
               </a:rPr>
               <a:t>Infrastructure lifecycle debt (4,210 unsupported component months, patch recency 63.18) is invisible to an incident count. This is precisely the signal the framework was built to surface.</a:t>
             </a:r>
-            <a:endParaRPr lang="en-US" sz="1300" dirty="0"/>
+            <a:endParaRPr lang="en-US" sz="1400" dirty="0"/>
           </a:p>
         </p:txBody>
       </p:sp>
@@ -2697,7 +2697,7 @@
               <a:buNone/>
             </a:pPr>
             <a:r>
-              <a:rPr lang="en-US" sz="1700" b="1" dirty="0">
+              <a:rPr lang="en-US" sz="1600" b="1" dirty="0">
                 <a:solidFill>
                   <a:srgbClr val="14283C"/>
                 </a:solidFill>
@@ -2707,7 +2707,7 @@
               </a:rPr>
               <a:t>SVC-05 falls, third to fifth</a:t>
             </a:r>
-            <a:endParaRPr lang="en-US" sz="1700" dirty="0"/>
+            <a:endParaRPr lang="en-US" sz="1600" dirty="0"/>
           </a:p>
         </p:txBody>
       </p:sp>
@@ -2739,7 +2739,7 @@
               <a:buNone/>
             </a:pPr>
             <a:r>
-              <a:rPr lang="en-US" sz="1300" dirty="0">
+              <a:rPr lang="en-US" sz="1400" dirty="0">
                 <a:solidFill>
                   <a:srgbClr val="2A3F55"/>
                 </a:solidFill>
@@ -2749,7 +2749,7 @@
               </a:rPr>
               <a:t>High incident volume (171/yr) offset by full patch recency and zero unsupported components: noisy, but structurally sound.</a:t>
             </a:r>
-            <a:endParaRPr lang="en-US" sz="1300" dirty="0"/>
+            <a:endParaRPr lang="en-US" sz="1400" dirty="0"/>
           </a:p>
         </p:txBody>
       </p:sp>
@@ -2761,7 +2761,7 @@
         </p:nvSpPr>
         <p:spPr>
           <a:xfrm>
-            <a:off x="685800" y="5120640"/>
+            <a:off x="685800" y="5850400"/>
             <a:ext cx="10789920" cy="713232"/>
           </a:xfrm>
           <a:prstGeom prst="rect">
@@ -2788,7 +2788,7 @@
         </p:nvSpPr>
         <p:spPr>
           <a:xfrm>
-            <a:off x="886968" y="5193792"/>
+            <a:off x="886968" y="5923552"/>
             <a:ext cx="10424160" cy="201168"/>
           </a:xfrm>
           <a:prstGeom prst="rect">
@@ -2827,7 +2827,7 @@
         </p:nvSpPr>
         <p:spPr>
           <a:xfrm>
-            <a:off x="886968" y="5394960"/>
+            <a:off x="886968" y="6124720"/>
             <a:ext cx="10424160" cy="384048"/>
           </a:xfrm>
           <a:prstGeom prst="rect">
@@ -2852,7 +2852,51 @@
                 <a:ea typeface="Arial" pitchFamily="34" charset="-122"/>
                 <a:cs typeface="Arial" pitchFamily="34" charset="-120"/>
               </a:rPr>
-              <a:t>The divergence is not noise; it concentrates exactly where multi-criteria measurement should add information over a single signal (Albarak &amp; Bahsoon, 2022).</a:t>
+              <a:t>The divergence is not noise; it concentrates exactly where multi-criteria measurement should add information over a single signal (</a:t>
+            </a:r>
+            <a:r>
+              <a:rPr lang="en-US" sz="1250" dirty="0" err="1">
+                <a:solidFill>
+                  <a:srgbClr val="14283C"/>
+                </a:solidFill>
+                <a:latin typeface="Arial" pitchFamily="34" charset="0"/>
+                <a:ea typeface="Arial" pitchFamily="34" charset="-122"/>
+                <a:cs typeface="Arial" pitchFamily="34" charset="-120"/>
+              </a:rPr>
+              <a:t>Albarak</a:t>
+            </a:r>
+            <a:r>
+              <a:rPr lang="en-US" sz="1250" dirty="0">
+                <a:solidFill>
+                  <a:srgbClr val="14283C"/>
+                </a:solidFill>
+                <a:latin typeface="Arial" pitchFamily="34" charset="0"/>
+                <a:ea typeface="Arial" pitchFamily="34" charset="-122"/>
+                <a:cs typeface="Arial" pitchFamily="34" charset="-120"/>
+              </a:rPr>
+              <a:t> </a:t>
+            </a:r>
+            <a:r>
+              <a:rPr lang="en-US" sz="1250" i="1" dirty="0">
+                <a:solidFill>
+                  <a:srgbClr val="14283C"/>
+                </a:solidFill>
+                <a:latin typeface="Arial" pitchFamily="34" charset="0"/>
+                <a:ea typeface="Arial" pitchFamily="34" charset="-122"/>
+                <a:cs typeface="Arial" pitchFamily="34" charset="-120"/>
+              </a:rPr>
+              <a:t>et al.</a:t>
+            </a:r>
+            <a:r>
+              <a:rPr lang="en-US" sz="1250" dirty="0">
+                <a:solidFill>
+                  <a:srgbClr val="14283C"/>
+                </a:solidFill>
+                <a:latin typeface="Arial" pitchFamily="34" charset="0"/>
+                <a:ea typeface="Arial" pitchFamily="34" charset="-122"/>
+                <a:cs typeface="Arial" pitchFamily="34" charset="-120"/>
+              </a:rPr>
+              <a:t>, 2022).</a:t>
             </a:r>
             <a:endParaRPr lang="en-US" sz="1250" dirty="0"/>
           </a:p>
@@ -2994,7 +3038,7 @@
               <a:buNone/>
             </a:pPr>
             <a:r>
-              <a:rPr lang="en-US" sz="1450" dirty="0">
+              <a:rPr lang="en-US" sz="1500" dirty="0">
                 <a:solidFill>
                   <a:srgbClr val="14283C"/>
                 </a:solidFill>
@@ -3005,7 +3049,7 @@
               <a:t>In 2025 all methods agree exactly under equal weights, with SVC-01 first. The one disagreement is the 2024 equal-weights top rank, and it is a </a:t>
             </a:r>
             <a:r>
-              <a:rPr lang="en-US" sz="1450" b="1" dirty="0">
+              <a:rPr lang="en-US" sz="1500" b="1" dirty="0">
                 <a:solidFill>
                   <a:srgbClr val="D98E1F"/>
                 </a:solidFill>
@@ -3015,7 +3059,7 @@
               </a:rPr>
               <a:t>photo-finish.</a:t>
             </a:r>
-            <a:endParaRPr lang="en-US" sz="1450" dirty="0"/>
+            <a:endParaRPr lang="en-US" sz="1500" dirty="0"/>
           </a:p>
         </p:txBody>
       </p:sp>
@@ -3028,14 +3072,14 @@
           <p:nvPr>
             <p:extLst>
               <p:ext uri="{D42A27DB-BD31-4B8C-83A1-F6EECF244321}">
-                <p14:modId xmlns:p14="http://schemas.microsoft.com/office/powerpoint/2010/main" val="1579011935"/>
+                <p14:modId xmlns:p14="http://schemas.microsoft.com/office/powerpoint/2010/main" val="2674304687"/>
               </p:ext>
             </p:extLst>
           </p:nvPr>
         </p:nvGraphicFramePr>
         <p:xfrm>
           <a:off x="685800" y="2377440"/>
-          <a:ext cx="7589520" cy="1920240"/>
+          <a:ext cx="7589520" cy="2188464"/>
         </p:xfrm>
         <a:graphic>
           <a:graphicData uri="http://schemas.openxmlformats.org/drawingml/2006/table">
@@ -3074,7 +3118,7 @@
                         <a:buNone/>
                       </a:pPr>
                       <a:r>
-                        <a:rPr lang="en-US" sz="1250" b="1" dirty="0">
+                        <a:rPr lang="en-US" sz="1400" b="1" dirty="0">
                           <a:solidFill>
                             <a:srgbClr val="14283C"/>
                           </a:solidFill>
@@ -3084,7 +3128,7 @@
                         </a:rPr>
                         <a:t>2024, equal weights</a:t>
                       </a:r>
-                      <a:endParaRPr lang="en-US" sz="1250" dirty="0">
+                      <a:endParaRPr lang="en-US" sz="1400" dirty="0">
                         <a:latin typeface="Arial" charset="0"/>
                         <a:ea typeface="Arial" charset="0"/>
                         <a:cs typeface="Arial" charset="0"/>
@@ -3121,7 +3165,7 @@
                         <a:buNone/>
                       </a:pPr>
                       <a:r>
-                        <a:rPr lang="en-US" sz="1250" b="1" dirty="0">
+                        <a:rPr lang="en-US" sz="1400" b="1" dirty="0">
                           <a:solidFill>
                             <a:srgbClr val="14283C"/>
                           </a:solidFill>
@@ -3131,7 +3175,7 @@
                         </a:rPr>
                         <a:t>TOPSIS classic</a:t>
                       </a:r>
-                      <a:endParaRPr lang="en-US" sz="1250" dirty="0">
+                      <a:endParaRPr lang="en-US" sz="1400" dirty="0">
                         <a:latin typeface="Arial" charset="0"/>
                         <a:ea typeface="Arial" charset="0"/>
                         <a:cs typeface="Arial" charset="0"/>
@@ -3168,7 +3212,7 @@
                         <a:buNone/>
                       </a:pPr>
                       <a:r>
-                        <a:rPr lang="en-US" sz="1250" b="1" dirty="0">
+                        <a:rPr lang="en-US" sz="1400" b="1" dirty="0">
                           <a:solidFill>
                             <a:srgbClr val="14283C"/>
                           </a:solidFill>
@@ -3178,7 +3222,7 @@
                         </a:rPr>
                         <a:t>SAW · VIKOR · TOPSIS absolute</a:t>
                       </a:r>
-                      <a:endParaRPr lang="en-US" sz="1250" dirty="0">
+                      <a:endParaRPr lang="en-US" sz="1400" dirty="0">
                         <a:latin typeface="Arial" charset="0"/>
                         <a:ea typeface="Arial" charset="0"/>
                         <a:cs typeface="Arial" charset="0"/>
@@ -3222,7 +3266,7 @@
                         <a:buNone/>
                       </a:pPr>
                       <a:r>
-                        <a:rPr lang="en-US" sz="1250" dirty="0">
+                        <a:rPr lang="en-US" sz="1400" dirty="0">
                           <a:solidFill>
                             <a:srgbClr val="14283C"/>
                           </a:solidFill>
@@ -3232,7 +3276,7 @@
                         </a:rPr>
                         <a:t>Top-ranked service</a:t>
                       </a:r>
-                      <a:endParaRPr lang="en-US" sz="1250" dirty="0">
+                      <a:endParaRPr lang="en-US" sz="1400" dirty="0">
                         <a:latin typeface="Arial" charset="0"/>
                         <a:ea typeface="Arial" charset="0"/>
                         <a:cs typeface="Arial" charset="0"/>
@@ -3275,7 +3319,7 @@
                         <a:buNone/>
                       </a:pPr>
                       <a:r>
-                        <a:rPr lang="en-US" sz="1250" dirty="0">
+                        <a:rPr lang="en-US" sz="1400" dirty="0">
                           <a:solidFill>
                             <a:srgbClr val="14283C"/>
                           </a:solidFill>
@@ -3285,7 +3329,7 @@
                         </a:rPr>
                         <a:t>SVC-04 (C* = 0.4847)</a:t>
                       </a:r>
-                      <a:endParaRPr lang="en-US" sz="1250" dirty="0">
+                      <a:endParaRPr lang="en-US" sz="1400" dirty="0">
                         <a:latin typeface="Arial" charset="0"/>
                         <a:ea typeface="Arial" charset="0"/>
                         <a:cs typeface="Arial" charset="0"/>
@@ -3328,7 +3372,7 @@
                         <a:buNone/>
                       </a:pPr>
                       <a:r>
-                        <a:rPr lang="en-US" sz="1250" dirty="0">
+                        <a:rPr lang="en-US" sz="1400" dirty="0">
                           <a:solidFill>
                             <a:srgbClr val="14283C"/>
                           </a:solidFill>
@@ -3338,7 +3382,7 @@
                         </a:rPr>
                         <a:t>SVC-01</a:t>
                       </a:r>
-                      <a:endParaRPr lang="en-US" sz="1250" dirty="0">
+                      <a:endParaRPr lang="en-US" sz="1400" dirty="0">
                         <a:latin typeface="Arial" charset="0"/>
                         <a:ea typeface="Arial" charset="0"/>
                         <a:cs typeface="Arial" charset="0"/>
@@ -3388,7 +3432,7 @@
                         <a:buNone/>
                       </a:pPr>
                       <a:r>
-                        <a:rPr lang="en-US" sz="1250" dirty="0">
+                        <a:rPr lang="en-US" sz="1400" dirty="0">
                           <a:solidFill>
                             <a:srgbClr val="14283C"/>
                           </a:solidFill>
@@ -3398,7 +3442,7 @@
                         </a:rPr>
                         <a:t>Margin</a:t>
                       </a:r>
-                      <a:endParaRPr lang="en-US" sz="1250" dirty="0">
+                      <a:endParaRPr lang="en-US" sz="1400" dirty="0">
                         <a:latin typeface="Arial" charset="0"/>
                         <a:ea typeface="Arial" charset="0"/>
                         <a:cs typeface="Arial" charset="0"/>
@@ -3441,7 +3485,7 @@
                         <a:buNone/>
                       </a:pPr>
                       <a:r>
-                        <a:rPr lang="en-US" sz="1250" dirty="0">
+                        <a:rPr lang="en-US" sz="1400" dirty="0">
                           <a:solidFill>
                             <a:srgbClr val="14283C"/>
                           </a:solidFill>
@@ -3451,7 +3495,7 @@
                         </a:rPr>
                         <a:t>ΔC* = 0.004 to SVC-01 (0.4886)</a:t>
                       </a:r>
-                      <a:endParaRPr lang="en-US" sz="1250" dirty="0">
+                      <a:endParaRPr lang="en-US" sz="1400" dirty="0">
                         <a:latin typeface="Arial" charset="0"/>
                         <a:ea typeface="Arial" charset="0"/>
                         <a:cs typeface="Arial" charset="0"/>
@@ -3494,7 +3538,7 @@
                         <a:buNone/>
                       </a:pPr>
                       <a:r>
-                        <a:rPr lang="en-US" sz="1250" dirty="0">
+                        <a:rPr lang="en-US" sz="1400" dirty="0">
                           <a:solidFill>
                             <a:srgbClr val="14283C"/>
                           </a:solidFill>
@@ -3502,9 +3546,9 @@
                           <a:ea typeface="Arial" pitchFamily="34" charset="-122"/>
                           <a:cs typeface="Arial" pitchFamily="34" charset="-120"/>
                         </a:rPr>
-                        <a:t>VIKOR regret capped on SVC-01</a:t>
+                        <a:t>Each worst on exactly 2 criteria</a:t>
                       </a:r>
-                      <a:endParaRPr lang="en-US" sz="1250" dirty="0">
+                      <a:endParaRPr lang="en-US" sz="1400" dirty="0">
                         <a:latin typeface="Arial" charset="0"/>
                         <a:ea typeface="Arial" charset="0"/>
                         <a:cs typeface="Arial" charset="0"/>
@@ -3554,7 +3598,7 @@
                         <a:buNone/>
                       </a:pPr>
                       <a:r>
-                        <a:rPr lang="en-US" sz="1250" dirty="0">
+                        <a:rPr lang="en-US" sz="1400" dirty="0">
                           <a:solidFill>
                             <a:srgbClr val="14283C"/>
                           </a:solidFill>
@@ -3564,7 +3608,7 @@
                         </a:rPr>
                         <a:t>Agreement</a:t>
                       </a:r>
-                      <a:endParaRPr lang="en-US" sz="1250" dirty="0">
+                      <a:endParaRPr lang="en-US" sz="1400" dirty="0">
                         <a:latin typeface="Arial" charset="0"/>
                         <a:ea typeface="Arial" charset="0"/>
                         <a:cs typeface="Arial" charset="0"/>
@@ -3607,7 +3651,7 @@
                         <a:buNone/>
                       </a:pPr>
                       <a:r>
-                        <a:rPr lang="en-US" sz="1250" dirty="0">
+                        <a:rPr lang="en-US" sz="1400" dirty="0">
                           <a:solidFill>
                             <a:srgbClr val="14283C"/>
                           </a:solidFill>
@@ -3617,7 +3661,7 @@
                         </a:rPr>
                         <a:t>vs SAW τ = 0.600</a:t>
                       </a:r>
-                      <a:endParaRPr lang="en-US" sz="1250" dirty="0">
+                      <a:endParaRPr lang="en-US" sz="1400" dirty="0">
                         <a:latin typeface="Arial" charset="0"/>
                         <a:ea typeface="Arial" charset="0"/>
                         <a:cs typeface="Arial" charset="0"/>
@@ -3660,7 +3704,7 @@
                         <a:buNone/>
                       </a:pPr>
                       <a:r>
-                        <a:rPr lang="en-US" sz="1250" dirty="0">
+                        <a:rPr lang="en-US" sz="1400" dirty="0">
                           <a:solidFill>
                             <a:srgbClr val="14283C"/>
                           </a:solidFill>
@@ -3670,7 +3714,7 @@
                         </a:rPr>
                         <a:t>absolute vs VIKOR τ = 1.000</a:t>
                       </a:r>
-                      <a:endParaRPr lang="en-US" sz="1250" dirty="0">
+                      <a:endParaRPr lang="en-US" sz="1400" dirty="0">
                         <a:latin typeface="Arial" charset="0"/>
                         <a:ea typeface="Arial" charset="0"/>
                         <a:cs typeface="Arial" charset="0"/>
@@ -3720,7 +3764,7 @@
                         <a:buNone/>
                       </a:pPr>
                       <a:r>
-                        <a:rPr lang="en-US" sz="1250" dirty="0">
+                        <a:rPr lang="en-US" sz="1400" dirty="0">
                           <a:solidFill>
                             <a:srgbClr val="14283C"/>
                           </a:solidFill>
@@ -3730,7 +3774,7 @@
                         </a:rPr>
                         <a:t>2025 and 2024 adjusted</a:t>
                       </a:r>
-                      <a:endParaRPr lang="en-US" sz="1250" dirty="0">
+                      <a:endParaRPr lang="en-US" sz="1400" dirty="0">
                         <a:latin typeface="Arial" charset="0"/>
                         <a:ea typeface="Arial" charset="0"/>
                         <a:cs typeface="Arial" charset="0"/>
@@ -3773,7 +3817,7 @@
                         <a:buNone/>
                       </a:pPr>
                       <a:r>
-                        <a:rPr lang="en-US" sz="1250" dirty="0">
+                        <a:rPr lang="en-US" sz="1400" dirty="0">
                           <a:solidFill>
                             <a:srgbClr val="14283C"/>
                           </a:solidFill>
@@ -3783,7 +3827,7 @@
                         </a:rPr>
                         <a:t>SVC-01 first under every method</a:t>
                       </a:r>
-                      <a:endParaRPr lang="en-US" sz="1250" dirty="0">
+                      <a:endParaRPr lang="en-US" sz="1400" dirty="0">
                         <a:latin typeface="Arial" charset="0"/>
                         <a:ea typeface="Arial" charset="0"/>
                         <a:cs typeface="Arial" charset="0"/>
@@ -3825,7 +3869,7 @@
                       <a:pPr marL="0" indent="0">
                         <a:buNone/>
                       </a:pPr>
-                      <a:endParaRPr lang="en-US" sz="1250" dirty="0">
+                      <a:endParaRPr lang="en-US" sz="1400" dirty="0">
                         <a:latin typeface="Arial" charset="0"/>
                         <a:ea typeface="Arial" charset="0"/>
                         <a:cs typeface="Arial" charset="0"/>
@@ -3877,8 +3921,8 @@
         </p:nvSpPr>
         <p:spPr>
           <a:xfrm>
-            <a:off x="8549640" y="2377440"/>
-            <a:ext cx="2926080" cy="2377440"/>
+            <a:off x="8549640" y="2377439"/>
+            <a:ext cx="2926080" cy="2458329"/>
           </a:xfrm>
           <a:prstGeom prst="rect">
             <a:avLst/>
@@ -3921,7 +3965,7 @@
               <a:buNone/>
             </a:pPr>
             <a:r>
-              <a:rPr lang="en-US" sz="1000" b="1" kern="0" spc="200" dirty="0">
+              <a:rPr lang="en-US" sz="1400" b="1" kern="0" spc="200" dirty="0">
                 <a:solidFill>
                   <a:srgbClr val="D98E1F"/>
                 </a:solidFill>
@@ -3931,7 +3975,7 @@
               </a:rPr>
               <a:t>MECHANISM</a:t>
             </a:r>
-            <a:endParaRPr lang="en-US" sz="1000" dirty="0"/>
+            <a:endParaRPr lang="en-US" sz="1400" dirty="0"/>
           </a:p>
         </p:txBody>
       </p:sp>
@@ -3963,7 +4007,7 @@
               <a:buNone/>
             </a:pPr>
             <a:r>
-              <a:rPr lang="en-US" sz="1050" dirty="0">
+              <a:rPr lang="en-US" sz="1400" dirty="0">
                 <a:solidFill>
                   <a:srgbClr val="2A3F55"/>
                 </a:solidFill>
@@ -3971,9 +4015,9 @@
                 <a:ea typeface="Arial" pitchFamily="34" charset="-122"/>
                 <a:cs typeface="Arial" pitchFamily="34" charset="-120"/>
               </a:rPr>
-              <a:t>Vector normalisation lets SVC-04’s 410-incident load dominate the incident axis. Fixed anchors and VIKOR’s regret register SVC-01’s concentrated structural exposure, the worst patch recency (65.83) and 4,054 unsupported months, at full strength.</a:t>
-            </a:r>
-            <a:endParaRPr lang="en-US" sz="1050" dirty="0"/>
+              <a:t>Both are worst on exactly two criteria. SVC-04 is perfect on the other two; SVC-01 is only good. Linear aggregation puts SVC-01 first; vector normalisation, preserving SVC-04’s outlying 410 incidents, reverses the pair by 0.004.</a:t>
+            </a:r>
+            <a:endParaRPr lang="en-US" sz="1400" dirty="0"/>
           </a:p>
         </p:txBody>
       </p:sp>
@@ -3985,7 +4029,7 @@
         </p:nvSpPr>
         <p:spPr>
           <a:xfrm>
-            <a:off x="685800" y="5074920"/>
+            <a:off x="685800" y="5822267"/>
             <a:ext cx="10789920" cy="713232"/>
           </a:xfrm>
           <a:prstGeom prst="rect">
@@ -4012,7 +4056,7 @@
         </p:nvSpPr>
         <p:spPr>
           <a:xfrm>
-            <a:off x="886968" y="5148072"/>
+            <a:off x="886968" y="5895419"/>
             <a:ext cx="10424160" cy="201168"/>
           </a:xfrm>
           <a:prstGeom prst="rect">
@@ -4051,7 +4095,7 @@
         </p:nvSpPr>
         <p:spPr>
           <a:xfrm>
-            <a:off x="886968" y="5349240"/>
+            <a:off x="886968" y="6096587"/>
             <a:ext cx="10424160" cy="384048"/>
           </a:xfrm>
           <a:prstGeom prst="rect">
@@ -4076,7 +4120,7 @@
                 <a:ea typeface="Arial" pitchFamily="34" charset="-122"/>
                 <a:cs typeface="Arial" pitchFamily="34" charset="-120"/>
               </a:rPr>
-              <a:t>Concentrated structural exposure versus diffuse operational load, separated by 0.004: the framework reports the photo-finish rather than hiding it. By 2025 every method places SVC-01 first.</a:t>
+              <a:t>A 0.004 margin decided by normalisation, not by a real gap. Three of four scorers say SVC-01. The framework reports the photo-finish rather than hiding it; by 2025 every method agrees.</a:t>
             </a:r>
             <a:endParaRPr lang="en-US" sz="1250" dirty="0"/>
           </a:p>
@@ -4264,7 +4308,7 @@
               <a:buChar char="•"/>
             </a:pPr>
             <a:r>
-              <a:rPr lang="en-US" sz="1350" dirty="0">
+              <a:rPr lang="en-US" sz="1500" dirty="0">
                 <a:solidFill>
                   <a:srgbClr val="14283C"/>
                 </a:solidFill>
@@ -4274,7 +4318,7 @@
               </a:rPr>
               <a:t>Primary prioritisation signal</a:t>
             </a:r>
-            <a:endParaRPr lang="en-US" sz="1350" dirty="0"/>
+            <a:endParaRPr lang="en-US" sz="1500" dirty="0"/>
           </a:p>
           <a:p>
             <a:pPr marL="177800" indent="-177800">
@@ -4288,7 +4332,7 @@
               <a:buChar char="•"/>
             </a:pPr>
             <a:r>
-              <a:rPr lang="en-US" sz="1350" dirty="0">
+              <a:rPr lang="en-US" sz="1500" dirty="0">
                 <a:solidFill>
                   <a:srgbClr val="14283C"/>
                 </a:solidFill>
@@ -4296,9 +4340,9 @@
                 <a:ea typeface="Arial" pitchFamily="34" charset="-122"/>
                 <a:cs typeface="Arial" pitchFamily="34" charset="-120"/>
               </a:rPr>
-              <a:t>VIKOR's regret and the absolute anchor both flag SVC-01's concentrated structural exposure, which distance aggregation alone underweights</a:t>
-            </a:r>
-            <a:endParaRPr lang="en-US" sz="1350" dirty="0"/>
+              <a:t>Triangulation, not a single number: where scorers split by 0.004, the margin is too small to carry a remediation decision</a:t>
+            </a:r>
+            <a:endParaRPr lang="en-US" sz="1500" dirty="0"/>
           </a:p>
         </p:txBody>
       </p:sp>
@@ -4373,7 +4417,7 @@
               <a:buChar char="•"/>
             </a:pPr>
             <a:r>
-              <a:rPr lang="en-US" sz="1350" dirty="0">
+              <a:rPr lang="en-US" sz="1500" dirty="0">
                 <a:solidFill>
                   <a:srgbClr val="14283C"/>
                 </a:solidFill>
@@ -4383,7 +4427,7 @@
               </a:rPr>
               <a:t>Rank-reversal free by construction: every leave-one-out removal preserved, where the classic top rank flips (García-Cascales &amp; Lamata 2012; Yang 2020)</a:t>
             </a:r>
-            <a:endParaRPr lang="en-US" sz="1350" dirty="0"/>
+            <a:endParaRPr lang="en-US" sz="1500" dirty="0"/>
           </a:p>
           <a:p>
             <a:pPr marL="177800" indent="-177800">
@@ -4397,7 +4441,7 @@
               <a:buChar char="•"/>
             </a:pPr>
             <a:r>
-              <a:rPr lang="en-US" sz="1350" dirty="0">
+              <a:rPr lang="en-US" sz="1500" dirty="0">
                 <a:solidFill>
                   <a:srgbClr val="14283C"/>
                 </a:solidFill>
@@ -4407,7 +4451,7 @@
               </a:rPr>
               <a:t>Scores comparable across observation periods, uniquely among the methods used</a:t>
             </a:r>
-            <a:endParaRPr lang="en-US" sz="1350" dirty="0"/>
+            <a:endParaRPr lang="en-US" sz="1500" dirty="0"/>
           </a:p>
           <a:p>
             <a:pPr marL="177800" indent="-177800">
@@ -4421,7 +4465,7 @@
               <a:buChar char="•"/>
             </a:pPr>
             <a:r>
-              <a:rPr lang="en-US" sz="1350" dirty="0">
+              <a:rPr lang="en-US" sz="1500" dirty="0">
                 <a:solidFill>
                   <a:srgbClr val="14283C"/>
                 </a:solidFill>
@@ -4431,7 +4475,7 @@
               </a:rPr>
               <a:t>Complementary perspective; also powers the Monte Carlo cleanly</a:t>
             </a:r>
-            <a:endParaRPr lang="en-US" sz="1350" dirty="0"/>
+            <a:endParaRPr lang="en-US" sz="1500" dirty="0"/>
           </a:p>
         </p:txBody>
       </p:sp>
@@ -4443,7 +4487,7 @@
         </p:nvSpPr>
         <p:spPr>
           <a:xfrm>
-            <a:off x="685800" y="5532120"/>
+            <a:off x="685800" y="5822265"/>
             <a:ext cx="10789920" cy="713232"/>
           </a:xfrm>
           <a:prstGeom prst="rect">
@@ -4470,7 +4514,7 @@
         </p:nvSpPr>
         <p:spPr>
           <a:xfrm>
-            <a:off x="886968" y="5605272"/>
+            <a:off x="886968" y="5895417"/>
             <a:ext cx="10424160" cy="201168"/>
           </a:xfrm>
           <a:prstGeom prst="rect">
@@ -4509,7 +4553,7 @@
         </p:nvSpPr>
         <p:spPr>
           <a:xfrm>
-            <a:off x="886968" y="5806440"/>
+            <a:off x="886968" y="6096585"/>
             <a:ext cx="10424160" cy="384048"/>
           </a:xfrm>
           <a:prstGeom prst="rect">
@@ -4676,7 +4720,7 @@
               <a:buNone/>
             </a:pPr>
             <a:r>
-              <a:rPr lang="en-US" sz="1500" b="1" dirty="0">
+              <a:rPr lang="en-US" sz="1600" b="1" dirty="0">
                 <a:solidFill>
                   <a:srgbClr val="D98E1F"/>
                 </a:solidFill>
@@ -4687,7 +4731,7 @@
               <a:t>Q  </a:t>
             </a:r>
             <a:r>
-              <a:rPr lang="en-US" sz="1500" b="1" dirty="0">
+              <a:rPr lang="en-US" sz="1600" b="1" dirty="0">
                 <a:solidFill>
                   <a:srgbClr val="14283C"/>
                 </a:solidFill>
@@ -4697,7 +4741,7 @@
               </a:rPr>
               <a:t>Only six services: what can that prove?</a:t>
             </a:r>
-            <a:endParaRPr lang="en-US" sz="1500" dirty="0"/>
+            <a:endParaRPr lang="en-US" sz="1600" dirty="0"/>
           </a:p>
         </p:txBody>
       </p:sp>
@@ -4709,8 +4753,8 @@
         </p:nvSpPr>
         <p:spPr>
           <a:xfrm>
-            <a:off x="1188720" y="2258568"/>
-            <a:ext cx="10149840" cy="731520"/>
+            <a:off x="1188720" y="2315473"/>
+            <a:ext cx="10149840" cy="563763"/>
           </a:xfrm>
           <a:prstGeom prst="rect">
             <a:avLst/>
@@ -4729,7 +4773,7 @@
               <a:buNone/>
             </a:pPr>
             <a:r>
-              <a:rPr lang="en-US" sz="1250" dirty="0">
+              <a:rPr lang="en-US" sz="1500" dirty="0">
                 <a:solidFill>
                   <a:srgbClr val="2A3F55"/>
                 </a:solidFill>
@@ -4739,7 +4783,7 @@
               </a:rPr>
               <a:t>The contribution is the instrument and evaluation logic, not a portfolio ranking. Selection was by data completeness; p-values are exact over all 720 permutations and read as effect sizes; portfolio-wide deployment is stated future work.</a:t>
             </a:r>
-            <a:endParaRPr lang="en-US" sz="1250" dirty="0"/>
+            <a:endParaRPr lang="en-US" sz="1500" dirty="0"/>
           </a:p>
         </p:txBody>
       </p:sp>
@@ -4751,7 +4795,7 @@
         </p:nvSpPr>
         <p:spPr>
           <a:xfrm>
-            <a:off x="685800" y="3191256"/>
+            <a:off x="685800" y="3043053"/>
             <a:ext cx="10789920" cy="347472"/>
           </a:xfrm>
           <a:prstGeom prst="rect">
@@ -4768,7 +4812,7 @@
               <a:buNone/>
             </a:pPr>
             <a:r>
-              <a:rPr lang="en-US" sz="1500" b="1" dirty="0">
+              <a:rPr lang="en-US" sz="1600" b="1" dirty="0">
                 <a:solidFill>
                   <a:srgbClr val="D98E1F"/>
                 </a:solidFill>
@@ -4779,7 +4823,7 @@
               <a:t>Q  </a:t>
             </a:r>
             <a:r>
-              <a:rPr lang="en-US" sz="1500" b="1" dirty="0">
+              <a:rPr lang="en-US" sz="1600" b="1" dirty="0">
                 <a:solidFill>
                   <a:srgbClr val="14283C"/>
                 </a:solidFill>
@@ -4789,7 +4833,7 @@
               </a:rPr>
               <a:t>You built and evaluated on the same data. Circular?</a:t>
             </a:r>
-            <a:endParaRPr lang="en-US" sz="1500" dirty="0"/>
+            <a:endParaRPr lang="en-US" sz="1600" dirty="0"/>
           </a:p>
         </p:txBody>
       </p:sp>
@@ -4801,8 +4845,8 @@
         </p:nvSpPr>
         <p:spPr>
           <a:xfrm>
-            <a:off x="1188720" y="3575304"/>
-            <a:ext cx="10149840" cy="731520"/>
+            <a:off x="1188720" y="3484006"/>
+            <a:ext cx="10149840" cy="768096"/>
           </a:xfrm>
           <a:prstGeom prst="rect">
             <a:avLst/>
@@ -4821,7 +4865,7 @@
               <a:buNone/>
             </a:pPr>
             <a:r>
-              <a:rPr lang="en-US" sz="1250" dirty="0">
+              <a:rPr lang="en-US" sz="1500" dirty="0">
                 <a:solidFill>
                   <a:srgbClr val="2A3F55"/>
                 </a:solidFill>
@@ -4831,7 +4875,7 @@
               </a:rPr>
               <a:t>Declared openly: the evaluation establishes robustness, method-independence and discriminant value, not criterion validity, because no independent measure of non-code debt exists. External validation is the primary future-work avenue.</a:t>
             </a:r>
-            <a:endParaRPr lang="en-US" sz="1250" dirty="0"/>
+            <a:endParaRPr lang="en-US" sz="1500" dirty="0"/>
           </a:p>
         </p:txBody>
       </p:sp>
@@ -4843,7 +4887,7 @@
         </p:nvSpPr>
         <p:spPr>
           <a:xfrm>
-            <a:off x="685800" y="4507992"/>
+            <a:off x="685800" y="4415919"/>
             <a:ext cx="10789920" cy="347472"/>
           </a:xfrm>
           <a:prstGeom prst="rect">
@@ -4860,7 +4904,7 @@
               <a:buNone/>
             </a:pPr>
             <a:r>
-              <a:rPr lang="en-US" sz="1500" b="1" dirty="0">
+              <a:rPr lang="en-US" sz="1600" b="1" dirty="0">
                 <a:solidFill>
                   <a:srgbClr val="D98E1F"/>
                 </a:solidFill>
@@ -4871,7 +4915,7 @@
               <a:t>Q  </a:t>
             </a:r>
             <a:r>
-              <a:rPr lang="en-US" sz="1500" b="1" dirty="0">
+              <a:rPr lang="en-US" sz="1600" b="1" dirty="0">
                 <a:solidFill>
                   <a:srgbClr val="14283C"/>
                 </a:solidFill>
@@ -4881,7 +4925,7 @@
               </a:rPr>
               <a:t>Are DORA metrics really debt proxies?</a:t>
             </a:r>
-            <a:endParaRPr lang="en-US" sz="1500" dirty="0"/>
+            <a:endParaRPr lang="en-US" sz="1600" dirty="0"/>
           </a:p>
         </p:txBody>
       </p:sp>
@@ -4893,8 +4937,8 @@
         </p:nvSpPr>
         <p:spPr>
           <a:xfrm>
-            <a:off x="1188720" y="4892040"/>
-            <a:ext cx="10149840" cy="731520"/>
+            <a:off x="1188720" y="4856871"/>
+            <a:ext cx="10149840" cy="805375"/>
           </a:xfrm>
           <a:prstGeom prst="rect">
             <a:avLst/>
@@ -4906,14 +4950,13 @@
           <a:bodyPr wrap="square" lIns="0" tIns="0" rIns="0" bIns="0" rtlCol="0" anchor="t"/>
           <a:lstStyle/>
           <a:p>
-            <a:pPr marL="0" indent="0">
+            <a:pPr>
               <a:lnSpc>
                 <a:spcPct val="112000"/>
               </a:lnSpc>
-              <a:buNone/>
-            </a:pPr>
-            <a:r>
-              <a:rPr lang="en-US" sz="1250" dirty="0">
+            </a:pPr>
+            <a:r>
+              <a:rPr lang="en-US" sz="1500" dirty="0">
                 <a:solidFill>
                   <a:srgbClr val="2A3F55"/>
                 </a:solidFill>
@@ -4921,9 +4964,53 @@
                 <a:ea typeface="Arial" pitchFamily="34" charset="-122"/>
                 <a:cs typeface="Arial" pitchFamily="34" charset="-120"/>
               </a:rPr>
-              <a:t>Treated as the central testable hypothesis, never a premise. Forsgren et al. validate the metrics; Nord et al. ground the diagnostic reading; the rankings match literature-predicted profiles. Longitudinal tracking would move it from plausible to evidenced.</a:t>
-            </a:r>
-            <a:endParaRPr lang="en-US" sz="1250" dirty="0"/>
+              <a:t>Treated as the central testable hypothesis, never a premise. Forsgren </a:t>
+            </a:r>
+            <a:r>
+              <a:rPr lang="en-US" sz="1500" i="1" dirty="0">
+                <a:solidFill>
+                  <a:srgbClr val="2A3F55"/>
+                </a:solidFill>
+                <a:latin typeface="Arial" pitchFamily="34" charset="0"/>
+                <a:ea typeface="Arial" pitchFamily="34" charset="-122"/>
+                <a:cs typeface="Arial" pitchFamily="34" charset="-120"/>
+              </a:rPr>
+              <a:t>et al. </a:t>
+            </a:r>
+            <a:r>
+              <a:rPr lang="en-US" sz="1500" dirty="0">
+                <a:solidFill>
+                  <a:srgbClr val="2A3F55"/>
+                </a:solidFill>
+                <a:latin typeface="Arial" pitchFamily="34" charset="0"/>
+                <a:ea typeface="Arial" pitchFamily="34" charset="-122"/>
+                <a:cs typeface="Arial" pitchFamily="34" charset="-120"/>
+              </a:rPr>
+              <a:t>(2018) validate the metrics; Nord, </a:t>
+            </a:r>
+            <a:r>
+              <a:rPr lang="en-US" sz="1500" dirty="0" err="1">
+                <a:solidFill>
+                  <a:srgbClr val="2A3F55"/>
+                </a:solidFill>
+                <a:latin typeface="Arial" pitchFamily="34" charset="0"/>
+                <a:ea typeface="Arial" pitchFamily="34" charset="-122"/>
+                <a:cs typeface="Arial" pitchFamily="34" charset="-120"/>
+              </a:rPr>
+              <a:t>Ozkaya</a:t>
+            </a:r>
+            <a:r>
+              <a:rPr lang="en-US" sz="1500" dirty="0">
+                <a:solidFill>
+                  <a:srgbClr val="2A3F55"/>
+                </a:solidFill>
+                <a:latin typeface="Arial" pitchFamily="34" charset="0"/>
+                <a:ea typeface="Arial" pitchFamily="34" charset="-122"/>
+                <a:cs typeface="Arial" pitchFamily="34" charset="-120"/>
+              </a:rPr>
+              <a:t> and Woody (2021) ground the diagnostic reading; the rankings match literature-predicted profiles. Longitudinal tracking would move it from plausible to evidenced.</a:t>
+            </a:r>
+            <a:endParaRPr lang="en-US" sz="1500" dirty="0"/>
           </a:p>
         </p:txBody>
       </p:sp>
@@ -5063,7 +5150,7 @@
               <a:buNone/>
             </a:pPr>
             <a:r>
-              <a:rPr lang="en-US" sz="1500" b="1" dirty="0">
+              <a:rPr lang="en-US" sz="1600" b="1" dirty="0">
                 <a:solidFill>
                   <a:srgbClr val="D98E1F"/>
                 </a:solidFill>
@@ -5074,7 +5161,7 @@
               <a:t>Q  </a:t>
             </a:r>
             <a:r>
-              <a:rPr lang="en-US" sz="1500" b="1" dirty="0">
+              <a:rPr lang="en-US" sz="1600" b="1" dirty="0">
                 <a:solidFill>
                   <a:srgbClr val="14283C"/>
                 </a:solidFill>
@@ -5084,7 +5171,7 @@
               </a:rPr>
               <a:t>Aren't the differential weights arbitrary?</a:t>
             </a:r>
-            <a:endParaRPr lang="en-US" sz="1500" dirty="0"/>
+            <a:endParaRPr lang="en-US" sz="1600" dirty="0"/>
           </a:p>
         </p:txBody>
       </p:sp>
@@ -5096,8 +5183,8 @@
         </p:nvSpPr>
         <p:spPr>
           <a:xfrm>
-            <a:off x="1188720" y="2258568"/>
-            <a:ext cx="10149840" cy="685800"/>
+            <a:off x="1188720" y="2256929"/>
+            <a:ext cx="10149840" cy="749804"/>
           </a:xfrm>
           <a:prstGeom prst="rect">
             <a:avLst/>
@@ -5116,7 +5203,7 @@
               <a:buNone/>
             </a:pPr>
             <a:r>
-              <a:rPr lang="en-US" sz="1250" dirty="0">
+              <a:rPr lang="en-US" sz="1500" dirty="0">
                 <a:solidFill>
                   <a:srgbClr val="2A3F55"/>
                 </a:solidFill>
@@ -5126,7 +5213,7 @@
               </a:rPr>
               <a:t>Yes, and they are declared as a practitioner assumption. That is why the evaluation does not depend on them: across 20,000 Dirichlet-sampled weightings the lowest priority holds in 98.3% of draws and rank 1 stays inside the same three-service cluster in all of them.</a:t>
             </a:r>
-            <a:endParaRPr lang="en-US" sz="1250" dirty="0"/>
+            <a:endParaRPr lang="en-US" sz="1500" dirty="0"/>
           </a:p>
         </p:txBody>
       </p:sp>
@@ -5138,7 +5225,7 @@
         </p:nvSpPr>
         <p:spPr>
           <a:xfrm>
-            <a:off x="685800" y="3145536"/>
+            <a:off x="685800" y="3112006"/>
             <a:ext cx="10789920" cy="347472"/>
           </a:xfrm>
           <a:prstGeom prst="rect">
@@ -5155,7 +5242,7 @@
               <a:buNone/>
             </a:pPr>
             <a:r>
-              <a:rPr lang="en-US" sz="1500" b="1" dirty="0">
+              <a:rPr lang="en-US" sz="1600" b="1" dirty="0">
                 <a:solidFill>
                   <a:srgbClr val="D98E1F"/>
                 </a:solidFill>
@@ -5166,7 +5253,7 @@
               <a:t>Q  </a:t>
             </a:r>
             <a:r>
-              <a:rPr lang="en-US" sz="1500" b="1" dirty="0">
+              <a:rPr lang="en-US" sz="1600" b="1" dirty="0">
                 <a:solidFill>
                   <a:srgbClr val="14283C"/>
                 </a:solidFill>
@@ -5176,7 +5263,7 @@
               </a:rPr>
               <a:t>Could this be misused to judge teams?</a:t>
             </a:r>
-            <a:endParaRPr lang="en-US" sz="1500" dirty="0"/>
+            <a:endParaRPr lang="en-US" sz="1600" dirty="0"/>
           </a:p>
         </p:txBody>
       </p:sp>
@@ -5188,8 +5275,8 @@
         </p:nvSpPr>
         <p:spPr>
           <a:xfrm>
-            <a:off x="1188720" y="3529584"/>
-            <a:ext cx="10149840" cy="914400"/>
+            <a:off x="1188720" y="3494416"/>
+            <a:ext cx="10149840" cy="787438"/>
           </a:xfrm>
           <a:prstGeom prst="rect">
             <a:avLst/>
@@ -5208,7 +5295,7 @@
               <a:buNone/>
             </a:pPr>
             <a:r>
-              <a:rPr lang="en-US" sz="1250" dirty="0">
+              <a:rPr lang="en-US" sz="1500" dirty="0">
                 <a:solidFill>
                   <a:srgbClr val="2A3F55"/>
                 </a:solidFill>
@@ -5216,9 +5303,31 @@
                 <a:ea typeface="Arial" pitchFamily="34" charset="-122"/>
                 <a:cs typeface="Arial" pitchFamily="34" charset="-120"/>
               </a:rPr>
-              <a:t>Governance scope was agreed with the Head of Trading IT at the outset: decision-support for portfolio conversations, not a binding instrument. High-debt profiles typically reflect historical design decisions, not current custodians (Ahmad et al., 2026). No team, vendor or individual identifiers exist in the dataset.</a:t>
-            </a:r>
-            <a:endParaRPr lang="en-US" sz="1250" dirty="0"/>
+              <a:t>Governance scope was agreed with the Head of Trading IT at the outset: decision-support for portfolio conversations, not a binding instrument. High-debt profiles typically reflect historical design decisions, not current custodians (Ahmad </a:t>
+            </a:r>
+            <a:r>
+              <a:rPr lang="en-US" sz="1500" i="1" dirty="0">
+                <a:solidFill>
+                  <a:srgbClr val="2A3F55"/>
+                </a:solidFill>
+                <a:latin typeface="Arial" pitchFamily="34" charset="0"/>
+                <a:ea typeface="Arial" pitchFamily="34" charset="-122"/>
+                <a:cs typeface="Arial" pitchFamily="34" charset="-120"/>
+              </a:rPr>
+              <a:t>et al.</a:t>
+            </a:r>
+            <a:r>
+              <a:rPr lang="en-US" sz="1500" dirty="0">
+                <a:solidFill>
+                  <a:srgbClr val="2A3F55"/>
+                </a:solidFill>
+                <a:latin typeface="Arial" pitchFamily="34" charset="0"/>
+                <a:ea typeface="Arial" pitchFamily="34" charset="-122"/>
+                <a:cs typeface="Arial" pitchFamily="34" charset="-120"/>
+              </a:rPr>
+              <a:t>, 2026). No team, vendor or individual identifiers exist in the dataset.</a:t>
+            </a:r>
+            <a:endParaRPr lang="en-US" sz="1500" dirty="0"/>
           </a:p>
         </p:txBody>
       </p:sp>
@@ -5230,7 +5339,7 @@
         </p:nvSpPr>
         <p:spPr>
           <a:xfrm>
-            <a:off x="685800" y="4690872"/>
+            <a:off x="685800" y="5833868"/>
             <a:ext cx="10789920" cy="713232"/>
           </a:xfrm>
           <a:prstGeom prst="rect">
@@ -5257,7 +5366,7 @@
         </p:nvSpPr>
         <p:spPr>
           <a:xfrm>
-            <a:off x="886968" y="4764024"/>
+            <a:off x="886968" y="5907020"/>
             <a:ext cx="10424160" cy="201168"/>
           </a:xfrm>
           <a:prstGeom prst="rect">
@@ -5296,7 +5405,7 @@
         </p:nvSpPr>
         <p:spPr>
           <a:xfrm>
-            <a:off x="886968" y="4965192"/>
+            <a:off x="886968" y="6108188"/>
             <a:ext cx="10424160" cy="384048"/>
           </a:xfrm>
           <a:prstGeom prst="rect">
@@ -5532,7 +5641,7 @@
               <a:buNone/>
             </a:pPr>
             <a:r>
-              <a:rPr lang="en-US" sz="1400" b="1" dirty="0">
+              <a:rPr lang="en-US" sz="1500" b="1" dirty="0">
                 <a:solidFill>
                   <a:srgbClr val="14283C"/>
                 </a:solidFill>
@@ -5543,7 +5652,7 @@
               <a:t>First application: </a:t>
             </a:r>
             <a:r>
-              <a:rPr lang="en-US" sz="1400" dirty="0">
+              <a:rPr lang="en-US" sz="1500" dirty="0">
                 <a:solidFill>
                   <a:srgbClr val="14283C"/>
                 </a:solidFill>
@@ -5551,9 +5660,31 @@
                 <a:ea typeface="Arial" pitchFamily="34" charset="-122"/>
                 <a:cs typeface="Arial" pitchFamily="34" charset="-120"/>
               </a:rPr>
-              <a:t>(to the best of current knowledge) of TOPSIS to live ITSM/CMDB records for TD prioritisation in financial trading IT, closing the gap Lenarduzzi et al. identify field-wide</a:t>
-            </a:r>
-            <a:endParaRPr lang="en-US" sz="1400" dirty="0"/>
+              <a:t>(to the best of current knowledge) of TOPSIS to live ITSM/CMDB records for TD prioritisation in financial trading IT, closing the gap Lenarduzzi </a:t>
+            </a:r>
+            <a:r>
+              <a:rPr lang="en-US" sz="1500" i="1" dirty="0">
+                <a:solidFill>
+                  <a:srgbClr val="14283C"/>
+                </a:solidFill>
+                <a:latin typeface="Arial" pitchFamily="34" charset="0"/>
+                <a:ea typeface="Arial" pitchFamily="34" charset="-122"/>
+                <a:cs typeface="Arial" pitchFamily="34" charset="-120"/>
+              </a:rPr>
+              <a:t>et al.</a:t>
+            </a:r>
+            <a:r>
+              <a:rPr lang="en-US" sz="1500" dirty="0">
+                <a:solidFill>
+                  <a:srgbClr val="14283C"/>
+                </a:solidFill>
+                <a:latin typeface="Arial" pitchFamily="34" charset="0"/>
+                <a:ea typeface="Arial" pitchFamily="34" charset="-122"/>
+                <a:cs typeface="Arial" pitchFamily="34" charset="-120"/>
+              </a:rPr>
+              <a:t> (2021) identify field-wide</a:t>
+            </a:r>
+            <a:endParaRPr lang="en-US" sz="1500" dirty="0"/>
           </a:p>
         </p:txBody>
       </p:sp>
@@ -5651,7 +5782,7 @@
               <a:buNone/>
             </a:pPr>
             <a:r>
-              <a:rPr lang="en-US" sz="1400" b="1" dirty="0">
+              <a:rPr lang="en-US" sz="1500" b="1" dirty="0">
                 <a:solidFill>
                   <a:srgbClr val="14283C"/>
                 </a:solidFill>
@@ -5662,7 +5793,7 @@
               <a:t>An operationally defined indicator set: </a:t>
             </a:r>
             <a:r>
-              <a:rPr lang="en-US" sz="1400" dirty="0">
+              <a:rPr lang="en-US" sz="1500" dirty="0">
                 <a:solidFill>
                   <a:srgbClr val="14283C"/>
                 </a:solidFill>
@@ -5672,7 +5803,7 @@
               </a:rPr>
               <a:t>with explicit literature mapping to debt dimensions, plus evidence of its behaviour under a four-strand evaluation</a:t>
             </a:r>
-            <a:endParaRPr lang="en-US" sz="1400" dirty="0"/>
+            <a:endParaRPr lang="en-US" sz="1500" dirty="0"/>
           </a:p>
         </p:txBody>
       </p:sp>
@@ -5770,7 +5901,7 @@
               <a:buNone/>
             </a:pPr>
             <a:r>
-              <a:rPr lang="en-US" sz="1400" b="1" dirty="0">
+              <a:rPr lang="en-US" sz="1500" b="1" dirty="0">
                 <a:solidFill>
                   <a:srgbClr val="14283C"/>
                 </a:solidFill>
@@ -5781,7 +5912,7 @@
               <a:t>A methodological finding of independent interest: </a:t>
             </a:r>
             <a:r>
-              <a:rPr lang="en-US" sz="1400" dirty="0">
+              <a:rPr lang="en-US" sz="1500" dirty="0">
                 <a:solidFill>
                   <a:srgbClr val="14283C"/>
                 </a:solidFill>
@@ -5791,7 +5922,7 @@
               </a:rPr>
               <a:t>sample-relative and absolutely anchored methods respond differently to concentrated debt profiles, consequential for the top of a ranking</a:t>
             </a:r>
-            <a:endParaRPr lang="en-US" sz="1400" dirty="0"/>
+            <a:endParaRPr lang="en-US" sz="1500" dirty="0"/>
           </a:p>
         </p:txBody>
       </p:sp>
@@ -5803,7 +5934,7 @@
         </p:nvSpPr>
         <p:spPr>
           <a:xfrm>
-            <a:off x="685800" y="5577840"/>
+            <a:off x="685800" y="5832817"/>
             <a:ext cx="10789920" cy="713232"/>
           </a:xfrm>
           <a:prstGeom prst="rect">
@@ -5830,7 +5961,7 @@
         </p:nvSpPr>
         <p:spPr>
           <a:xfrm>
-            <a:off x="886968" y="5650992"/>
+            <a:off x="886968" y="5905969"/>
             <a:ext cx="10424160" cy="201168"/>
           </a:xfrm>
           <a:prstGeom prst="rect">
@@ -5869,7 +6000,7 @@
         </p:nvSpPr>
         <p:spPr>
           <a:xfrm>
-            <a:off x="886968" y="5852160"/>
+            <a:off x="886968" y="6107137"/>
             <a:ext cx="10424160" cy="384048"/>
           </a:xfrm>
           <a:prstGeom prst="rect">
@@ -6523,7 +6654,7 @@
         <p:spPr>
           <a:xfrm>
             <a:off x="685800" y="1828800"/>
-            <a:ext cx="5303520" cy="649224"/>
+            <a:ext cx="5303520" cy="498348"/>
           </a:xfrm>
           <a:prstGeom prst="rect">
             <a:avLst/>
@@ -6550,7 +6681,29 @@
                 <a:ea typeface="Arial" pitchFamily="34" charset="-122"/>
                 <a:cs typeface="Arial" pitchFamily="34" charset="-120"/>
               </a:rPr>
-              <a:t>Ahmad, M.O., Mandić, V., Taušan, N., Katin, A. and Herath, P. (2026) 'Technical debt is not just technical: An industrial case study in large agile software development', Journal of Systems and Software, 234, p. 112719. Available at: https://doi.org/10.1016/j.jss.2025.112719.</a:t>
+              <a:t>Ahmad, M.O., Mandić, V., Taušan, N., Katin, A. and Herath, P. (2026) 'Technical debt is not just technical: An industrial case study in large agile software development', </a:t>
+            </a:r>
+            <a:r>
+              <a:rPr lang="en-US" sz="950" i="1" dirty="0">
+                <a:solidFill>
+                  <a:srgbClr val="2A3F55"/>
+                </a:solidFill>
+                <a:latin typeface="Arial" pitchFamily="34" charset="0"/>
+                <a:ea typeface="Arial" pitchFamily="34" charset="-122"/>
+                <a:cs typeface="Arial" pitchFamily="34" charset="-120"/>
+              </a:rPr>
+              <a:t>Journal of Systems and Software</a:t>
+            </a:r>
+            <a:r>
+              <a:rPr lang="en-US" sz="950" dirty="0">
+                <a:solidFill>
+                  <a:srgbClr val="2A3F55"/>
+                </a:solidFill>
+                <a:latin typeface="Arial" pitchFamily="34" charset="0"/>
+                <a:ea typeface="Arial" pitchFamily="34" charset="-122"/>
+                <a:cs typeface="Arial" pitchFamily="34" charset="-120"/>
+              </a:rPr>
+              <a:t>, 234, p. 112719. Available at: https://doi.org/10.1016/j.jss.2025.112719.</a:t>
             </a:r>
             <a:endParaRPr lang="en-US" sz="950" dirty="0"/>
           </a:p>
@@ -6564,7 +6717,7 @@
         </p:nvSpPr>
         <p:spPr>
           <a:xfrm>
-            <a:off x="685800" y="2606040"/>
+            <a:off x="685800" y="2549488"/>
             <a:ext cx="5303520" cy="498348"/>
           </a:xfrm>
           <a:prstGeom prst="rect">
@@ -6592,7 +6745,29 @@
                 <a:ea typeface="Arial" pitchFamily="34" charset="-122"/>
                 <a:cs typeface="Arial" pitchFamily="34" charset="-120"/>
               </a:rPr>
-              <a:t>Albarak, M., Bahsoon, R., Ozkaya, I. and Nord, R.L. (2022) 'Managing Technical Debt in Database Normalization', IEEE Transactions on Software Engineering, 48(3), pp. 755–772. Available at: https://doi.org/10.1109/TSE.2020.3001339.</a:t>
+              <a:t>Albarak, M., Bahsoon, R., Ozkaya, I. and Nord, R.L. (2022) 'Managing Technical Debt in Database Normalization', </a:t>
+            </a:r>
+            <a:r>
+              <a:rPr lang="en-US" sz="950" i="1" dirty="0">
+                <a:solidFill>
+                  <a:srgbClr val="2A3F55"/>
+                </a:solidFill>
+                <a:latin typeface="Arial" pitchFamily="34" charset="0"/>
+                <a:ea typeface="Arial" pitchFamily="34" charset="-122"/>
+                <a:cs typeface="Arial" pitchFamily="34" charset="-120"/>
+              </a:rPr>
+              <a:t>IEEE Transactions on Software Engineering</a:t>
+            </a:r>
+            <a:r>
+              <a:rPr lang="en-US" sz="950" dirty="0">
+                <a:solidFill>
+                  <a:srgbClr val="2A3F55"/>
+                </a:solidFill>
+                <a:latin typeface="Arial" pitchFamily="34" charset="0"/>
+                <a:ea typeface="Arial" pitchFamily="34" charset="-122"/>
+                <a:cs typeface="Arial" pitchFamily="34" charset="-120"/>
+              </a:rPr>
+              <a:t>, 48(3), pp. 755–772. Available at: https://doi.org/10.1109/TSE.2020.3001339.</a:t>
             </a:r>
             <a:endParaRPr lang="en-US" sz="950" dirty="0"/>
           </a:p>
@@ -6606,8 +6781,8 @@
         </p:nvSpPr>
         <p:spPr>
           <a:xfrm>
-            <a:off x="685800" y="3232404"/>
-            <a:ext cx="5303520" cy="498348"/>
+            <a:off x="685800" y="3270176"/>
+            <a:ext cx="5303520" cy="328481"/>
           </a:xfrm>
           <a:prstGeom prst="rect">
             <a:avLst/>
@@ -6648,8 +6823,8 @@
         </p:nvSpPr>
         <p:spPr>
           <a:xfrm>
-            <a:off x="685800" y="3858768"/>
-            <a:ext cx="5303520" cy="800100"/>
+            <a:off x="685800" y="3820997"/>
+            <a:ext cx="5303520" cy="649224"/>
           </a:xfrm>
           <a:prstGeom prst="rect">
             <a:avLst/>
@@ -6676,7 +6851,29 @@
                 <a:ea typeface="Arial" pitchFamily="34" charset="-122"/>
                 <a:cs typeface="Arial" pitchFamily="34" charset="-120"/>
               </a:rPr>
-              <a:t>de Toledo, S.S., Martini, A., Sjøberg, D.I.K., Przybyszewska, A. and Frandsen, J.S. (2021) 'Reducing Incidents in Microservices by Repaying Architectural Technical Debt', 2021 47th Euromicro Conference on Software Engineering and Advanced Applications (SEAA). 2021 47th Euromicro Conference on Software Engineering and Advanced Applications (SEAA), pp. 196–205. Available at: https://doi.org/10.1109/SEAA53835.2021.00033.</a:t>
+              <a:t>de Toledo, S.S., Martini, A., Sjøberg, D.I.K., Przybyszewska, A. and Frandsen, J.S. (2021) 'Reducing Incidents in Microservices by Repaying Architectural Technical Debt', </a:t>
+            </a:r>
+            <a:r>
+              <a:rPr lang="en-US" sz="950" i="1" dirty="0">
+                <a:solidFill>
+                  <a:srgbClr val="2A3F55"/>
+                </a:solidFill>
+                <a:latin typeface="Arial" pitchFamily="34" charset="0"/>
+                <a:ea typeface="Arial" pitchFamily="34" charset="-122"/>
+                <a:cs typeface="Arial" pitchFamily="34" charset="-120"/>
+              </a:rPr>
+              <a:t>2021 47th Euromicro Conference on Software Engineering and Advanced Applications (SEAA)</a:t>
+            </a:r>
+            <a:r>
+              <a:rPr lang="en-US" sz="950" dirty="0">
+                <a:solidFill>
+                  <a:srgbClr val="2A3F55"/>
+                </a:solidFill>
+                <a:latin typeface="Arial" pitchFamily="34" charset="0"/>
+                <a:ea typeface="Arial" pitchFamily="34" charset="-122"/>
+                <a:cs typeface="Arial" pitchFamily="34" charset="-120"/>
+              </a:rPr>
+              <a:t>, pp. 196–205. Available at: https://doi.org/10.1109/SEAA53835.2021.00033.</a:t>
             </a:r>
             <a:endParaRPr lang="en-US" sz="950" dirty="0"/>
           </a:p>
@@ -6690,7 +6887,7 @@
         </p:nvSpPr>
         <p:spPr>
           <a:xfrm>
-            <a:off x="685800" y="4786884"/>
+            <a:off x="685800" y="4692561"/>
             <a:ext cx="5303520" cy="498348"/>
           </a:xfrm>
           <a:prstGeom prst="rect">
@@ -6710,6 +6907,17 @@
               <a:buNone/>
             </a:pPr>
             <a:r>
+              <a:rPr lang="en-US" sz="950" i="1" dirty="0">
+                <a:solidFill>
+                  <a:srgbClr val="2A3F55"/>
+                </a:solidFill>
+                <a:latin typeface="Arial" pitchFamily="34" charset="0"/>
+                <a:ea typeface="Arial" pitchFamily="34" charset="-122"/>
+                <a:cs typeface="Arial" pitchFamily="34" charset="-120"/>
+              </a:rPr>
+              <a:t>FINMA Circular 2023/1 - Operational risks and resilience – banks </a:t>
+            </a:r>
+            <a:r>
               <a:rPr lang="en-US" sz="950" dirty="0">
                 <a:solidFill>
                   <a:srgbClr val="2A3F55"/>
@@ -6718,7 +6926,7 @@
                 <a:ea typeface="Arial" pitchFamily="34" charset="-122"/>
                 <a:cs typeface="Arial" pitchFamily="34" charset="-120"/>
               </a:rPr>
-              <a:t>FINMA Circular 2023/1 - Operational risks and resilience – banks (2024). Available at: https://www.finma.ch/en/~/media/finma/dokumente/dokumentencenter/myfinma/rundschreiben/finma-rs-2023-01-20221207.pdf (Accessed: March 29, 2026).</a:t>
+              <a:t>(2024). Available at: https://www.finma.ch/en/~/media/finma/dokumente/dokumentencenter/myfinma/rundschreiben/finma-rs-2023-01-20221207.pdf (Accessed: March 29, 2026).</a:t>
             </a:r>
             <a:endParaRPr lang="en-US" sz="950" dirty="0"/>
           </a:p>
@@ -6760,7 +6968,29 @@
                 <a:ea typeface="Arial" pitchFamily="34" charset="-122"/>
                 <a:cs typeface="Arial" pitchFamily="34" charset="-120"/>
               </a:rPr>
-              <a:t>Forsgren, N., Humble, J. and Kim, G. (2018) Accelerate: The Science of Lean Software and DevOps: Building and Scaling High Performing Technology Organizations. Portland, OR: IT Revolution Press.</a:t>
+              <a:t>Forsgren, N., Humble, J. and Kim, G. (2018) </a:t>
+            </a:r>
+            <a:r>
+              <a:rPr lang="en-US" sz="950" i="1" dirty="0">
+                <a:solidFill>
+                  <a:srgbClr val="2A3F55"/>
+                </a:solidFill>
+                <a:latin typeface="Arial" pitchFamily="34" charset="0"/>
+                <a:ea typeface="Arial" pitchFamily="34" charset="-122"/>
+                <a:cs typeface="Arial" pitchFamily="34" charset="-120"/>
+              </a:rPr>
+              <a:t>Accelerate: The Science of Lean Software and DevOps: Building and Scaling High Performing Technology Organizations</a:t>
+            </a:r>
+            <a:r>
+              <a:rPr lang="en-US" sz="950" dirty="0">
+                <a:solidFill>
+                  <a:srgbClr val="2A3F55"/>
+                </a:solidFill>
+                <a:latin typeface="Arial" pitchFamily="34" charset="0"/>
+                <a:ea typeface="Arial" pitchFamily="34" charset="-122"/>
+                <a:cs typeface="Arial" pitchFamily="34" charset="-120"/>
+              </a:rPr>
+              <a:t>. Portland, OR: IT Revolution Press.</a:t>
             </a:r>
             <a:endParaRPr lang="en-US" sz="950" dirty="0"/>
           </a:p>
@@ -6774,7 +7004,7 @@
         </p:nvSpPr>
         <p:spPr>
           <a:xfrm>
-            <a:off x="6217920" y="1828800"/>
+            <a:off x="6217920" y="1831614"/>
             <a:ext cx="5303520" cy="498348"/>
           </a:xfrm>
           <a:prstGeom prst="rect">
@@ -6802,7 +7032,29 @@
                 <a:ea typeface="Arial" pitchFamily="34" charset="-122"/>
                 <a:cs typeface="Arial" pitchFamily="34" charset="-120"/>
               </a:rPr>
-              <a:t>García-Cascales, M.S. and Lamata, M.T. (2012) 'On rank reversal and TOPSIS method', Mathematical and Computer Modelling, 56(5), pp. 123–132. Available at: https://doi.org/10.1016/j.mcm.2011.12.022.</a:t>
+              <a:t>García-Cascales, M.S. and Lamata, M.T. (2012) 'On rank reversal and TOPSIS method', </a:t>
+            </a:r>
+            <a:r>
+              <a:rPr lang="en-US" sz="950" i="1" dirty="0">
+                <a:solidFill>
+                  <a:srgbClr val="2A3F55"/>
+                </a:solidFill>
+                <a:latin typeface="Arial" pitchFamily="34" charset="0"/>
+                <a:ea typeface="Arial" pitchFamily="34" charset="-122"/>
+                <a:cs typeface="Arial" pitchFamily="34" charset="-120"/>
+              </a:rPr>
+              <a:t>Mathematical and Computer Modelling</a:t>
+            </a:r>
+            <a:r>
+              <a:rPr lang="en-US" sz="950" dirty="0">
+                <a:solidFill>
+                  <a:srgbClr val="2A3F55"/>
+                </a:solidFill>
+                <a:latin typeface="Arial" pitchFamily="34" charset="0"/>
+                <a:ea typeface="Arial" pitchFamily="34" charset="-122"/>
+                <a:cs typeface="Arial" pitchFamily="34" charset="-120"/>
+              </a:rPr>
+              <a:t>, 56(5), pp. 123–132. Available at: https://doi.org/10.1016/j.mcm.2011.12.022.</a:t>
             </a:r>
             <a:endParaRPr lang="en-US" sz="950" dirty="0"/>
           </a:p>
@@ -6816,8 +7068,8 @@
         </p:nvSpPr>
         <p:spPr>
           <a:xfrm>
-            <a:off x="6217920" y="2455164"/>
-            <a:ext cx="5303520" cy="498348"/>
+            <a:off x="6217920" y="2549207"/>
+            <a:ext cx="5303520" cy="331998"/>
           </a:xfrm>
           <a:prstGeom prst="rect">
             <a:avLst/>
@@ -6844,7 +7096,29 @@
                 <a:ea typeface="Arial" pitchFamily="34" charset="-122"/>
                 <a:cs typeface="Arial" pitchFamily="34" charset="-120"/>
               </a:rPr>
-              <a:t>Hevner, A.R., March, S.T., Park, J. and Ram, S. (2004) 'Design Science in Information Systems Research', MIS Quarterly, 28(1), pp. 75–105. Available at: https://doi.org/10.2307/25148625.</a:t>
+              <a:t>Hevner, A.R., March, S.T., Park, J. and Ram, S. (2004) 'Design Science in Information Systems Research', </a:t>
+            </a:r>
+            <a:r>
+              <a:rPr lang="en-US" sz="950" i="1" dirty="0">
+                <a:solidFill>
+                  <a:srgbClr val="2A3F55"/>
+                </a:solidFill>
+                <a:latin typeface="Arial" pitchFamily="34" charset="0"/>
+                <a:ea typeface="Arial" pitchFamily="34" charset="-122"/>
+                <a:cs typeface="Arial" pitchFamily="34" charset="-120"/>
+              </a:rPr>
+              <a:t>MIS Quarterly</a:t>
+            </a:r>
+            <a:r>
+              <a:rPr lang="en-US" sz="950" dirty="0">
+                <a:solidFill>
+                  <a:srgbClr val="2A3F55"/>
+                </a:solidFill>
+                <a:latin typeface="Arial" pitchFamily="34" charset="0"/>
+                <a:ea typeface="Arial" pitchFamily="34" charset="-122"/>
+                <a:cs typeface="Arial" pitchFamily="34" charset="-120"/>
+              </a:rPr>
+              <a:t>, 28(1), pp. 75–105. Available at: https://doi.org/10.2307/25148625.</a:t>
             </a:r>
             <a:endParaRPr lang="en-US" sz="950" dirty="0"/>
           </a:p>
@@ -6858,8 +7132,8 @@
         </p:nvSpPr>
         <p:spPr>
           <a:xfrm>
-            <a:off x="6217920" y="3081528"/>
-            <a:ext cx="5303520" cy="649224"/>
+            <a:off x="6217920" y="3100309"/>
+            <a:ext cx="5303520" cy="498348"/>
           </a:xfrm>
           <a:prstGeom prst="rect">
             <a:avLst/>
@@ -6886,7 +7160,29 @@
                 <a:ea typeface="Arial" pitchFamily="34" charset="-122"/>
                 <a:cs typeface="Arial" pitchFamily="34" charset="-120"/>
               </a:rPr>
-              <a:t>Lenarduzzi, V., Besker, T., Taibi, D., Martini, A. and Arcelli Fontana, F. (2021) 'A systematic literature review on Technical Debt prioritization: Strategies, processes, factors, and tools', Journal of Systems and Software, 171, p. 110827. Available at: https://doi.org/10.1016/j.jss.2020.110827.</a:t>
+              <a:t>Lenarduzzi, V., Besker, T., Taibi, D., Martini, A. and Arcelli Fontana, F. (2021) 'A systematic literature review on Technical Debt prioritization: Strategies, processes, factors, and tools', </a:t>
+            </a:r>
+            <a:r>
+              <a:rPr lang="en-US" sz="950" i="1" dirty="0">
+                <a:solidFill>
+                  <a:srgbClr val="2A3F55"/>
+                </a:solidFill>
+                <a:latin typeface="Arial" pitchFamily="34" charset="0"/>
+                <a:ea typeface="Arial" pitchFamily="34" charset="-122"/>
+                <a:cs typeface="Arial" pitchFamily="34" charset="-120"/>
+              </a:rPr>
+              <a:t>Journal of Systems and Software</a:t>
+            </a:r>
+            <a:r>
+              <a:rPr lang="en-US" sz="950" dirty="0">
+                <a:solidFill>
+                  <a:srgbClr val="2A3F55"/>
+                </a:solidFill>
+                <a:latin typeface="Arial" pitchFamily="34" charset="0"/>
+                <a:ea typeface="Arial" pitchFamily="34" charset="-122"/>
+                <a:cs typeface="Arial" pitchFamily="34" charset="-120"/>
+              </a:rPr>
+              <a:t>, 171, p. 110827. Available at: https://doi.org/10.1016/j.jss.2020.110827.</a:t>
             </a:r>
             <a:endParaRPr lang="en-US" sz="950" dirty="0"/>
           </a:p>
@@ -6900,7 +7196,7 @@
         </p:nvSpPr>
         <p:spPr>
           <a:xfrm>
-            <a:off x="6217920" y="3858768"/>
+            <a:off x="6217920" y="3817761"/>
             <a:ext cx="5303520" cy="498348"/>
           </a:xfrm>
           <a:prstGeom prst="rect">
@@ -6928,7 +7224,29 @@
                 <a:ea typeface="Arial" pitchFamily="34" charset="-122"/>
                 <a:cs typeface="Arial" pitchFamily="34" charset="-120"/>
               </a:rPr>
-              <a:t>Nord, R.L., Ozkaya, I. and Woody, C. (2021) Examples of Technical Debt’s Cybersecurity Impact. Pittsburgh, PA, USA: Carnegie Mellon University, pp. 1–21. Available at: https://apps.dtic.mil/sti/trecms/pdf/AD1144728.pdf (Accessed: April 27, 2026).</a:t>
+              <a:t>Nord, R.L., Ozkaya, I. and Woody, C. (2021) </a:t>
+            </a:r>
+            <a:r>
+              <a:rPr lang="en-US" sz="950" i="1" dirty="0">
+                <a:solidFill>
+                  <a:srgbClr val="2A3F55"/>
+                </a:solidFill>
+                <a:latin typeface="Arial" pitchFamily="34" charset="0"/>
+                <a:ea typeface="Arial" pitchFamily="34" charset="-122"/>
+                <a:cs typeface="Arial" pitchFamily="34" charset="-120"/>
+              </a:rPr>
+              <a:t>Examples of Technical Debt’s Cybersecurity Impact</a:t>
+            </a:r>
+            <a:r>
+              <a:rPr lang="en-US" sz="950" dirty="0">
+                <a:solidFill>
+                  <a:srgbClr val="2A3F55"/>
+                </a:solidFill>
+                <a:latin typeface="Arial" pitchFamily="34" charset="0"/>
+                <a:ea typeface="Arial" pitchFamily="34" charset="-122"/>
+                <a:cs typeface="Arial" pitchFamily="34" charset="-120"/>
+              </a:rPr>
+              <a:t>. Pittsburgh, PA, USA: Carnegie Mellon University, pp. 1–21. Available at: https://apps.dtic.mil/sti/trecms/pdf/AD1144728.pdf (Accessed: April 27, 2026).</a:t>
             </a:r>
             <a:endParaRPr lang="en-US" sz="950" dirty="0"/>
           </a:p>
@@ -6942,8 +7260,8 @@
         </p:nvSpPr>
         <p:spPr>
           <a:xfrm>
-            <a:off x="6217920" y="4485132"/>
-            <a:ext cx="5303520" cy="649224"/>
+            <a:off x="6217920" y="4530149"/>
+            <a:ext cx="5303520" cy="498348"/>
           </a:xfrm>
           <a:prstGeom prst="rect">
             <a:avLst/>
@@ -6970,7 +7288,29 @@
                 <a:ea typeface="Arial" pitchFamily="34" charset="-122"/>
                 <a:cs typeface="Arial" pitchFamily="34" charset="-120"/>
               </a:rPr>
-              <a:t>Tizio, G.D., Armellini, M. and Massacci, F. (2023) 'Software Updates Strategies: A Quantitative Evaluation Against Advanced Persistent Threats', IEEE Transactions on Software Engineering, 49(3), pp. 1359–1373. Available at: https://doi.org/10.1109/TSE.2022.3176674.</a:t>
+              <a:t>Tizio, G.D., Armellini, M. and Massacci, F. (2023) 'Software Updates Strategies: A Quantitative Evaluation Against Advanced Persistent Threats', </a:t>
+            </a:r>
+            <a:r>
+              <a:rPr lang="en-US" sz="950" i="1" dirty="0">
+                <a:solidFill>
+                  <a:srgbClr val="2A3F55"/>
+                </a:solidFill>
+                <a:latin typeface="Arial" pitchFamily="34" charset="0"/>
+                <a:ea typeface="Arial" pitchFamily="34" charset="-122"/>
+                <a:cs typeface="Arial" pitchFamily="34" charset="-120"/>
+              </a:rPr>
+              <a:t>IEEE Transactions on Software Engineering</a:t>
+            </a:r>
+            <a:r>
+              <a:rPr lang="en-US" sz="950" dirty="0">
+                <a:solidFill>
+                  <a:srgbClr val="2A3F55"/>
+                </a:solidFill>
+                <a:latin typeface="Arial" pitchFamily="34" charset="0"/>
+                <a:ea typeface="Arial" pitchFamily="34" charset="-122"/>
+                <a:cs typeface="Arial" pitchFamily="34" charset="-120"/>
+              </a:rPr>
+              <a:t>, 49(3), pp. 1359–1373. Available at: https://doi.org/10.1109/TSE.2022.3176674.</a:t>
             </a:r>
             <a:endParaRPr lang="en-US" sz="950" dirty="0"/>
           </a:p>
@@ -6984,7 +7324,7 @@
         </p:nvSpPr>
         <p:spPr>
           <a:xfrm>
-            <a:off x="6217920" y="5262372"/>
+            <a:off x="6217920" y="5242537"/>
             <a:ext cx="5303520" cy="498348"/>
           </a:xfrm>
           <a:prstGeom prst="rect">
@@ -7012,7 +7352,29 @@
                 <a:ea typeface="Arial" pitchFamily="34" charset="-122"/>
                 <a:cs typeface="Arial" pitchFamily="34" charset="-120"/>
               </a:rPr>
-              <a:t>Yang, W. (2020) 'Ingenious Solution for the Rank Reversal Problem of TOPSIS Method', Mathematical Problems in Engineering, 2020(1), p. 9676518. Available at: https://doi.org/10.1155/2020/9676518.</a:t>
+              <a:t>Yang, W. (2020) 'Ingenious Solution for the Rank Reversal Problem of TOPSIS Method', </a:t>
+            </a:r>
+            <a:r>
+              <a:rPr lang="en-US" sz="950" i="1" dirty="0">
+                <a:solidFill>
+                  <a:srgbClr val="2A3F55"/>
+                </a:solidFill>
+                <a:latin typeface="Arial" pitchFamily="34" charset="0"/>
+                <a:ea typeface="Arial" pitchFamily="34" charset="-122"/>
+                <a:cs typeface="Arial" pitchFamily="34" charset="-120"/>
+              </a:rPr>
+              <a:t>Mathematical Problems in Engineering</a:t>
+            </a:r>
+            <a:r>
+              <a:rPr lang="en-US" sz="950" dirty="0">
+                <a:solidFill>
+                  <a:srgbClr val="2A3F55"/>
+                </a:solidFill>
+                <a:latin typeface="Arial" pitchFamily="34" charset="0"/>
+                <a:ea typeface="Arial" pitchFamily="34" charset="-122"/>
+                <a:cs typeface="Arial" pitchFamily="34" charset="-120"/>
+              </a:rPr>
+              <a:t>, 2020(1), p. 9676518. Available at: https://doi.org/10.1155/2020/9676518.</a:t>
             </a:r>
             <a:endParaRPr lang="en-US" sz="950" dirty="0"/>
           </a:p>
@@ -7329,7 +7691,29 @@
                 <a:ea typeface="Arial" pitchFamily="34" charset="-122"/>
                 <a:cs typeface="Arial" pitchFamily="34" charset="-120"/>
               </a:rPr>
-              <a:t>gross return on assets per 10% more technical debt in COTS platforms (Banker et al., 2020)</a:t>
+              <a:t>gross return on assets per 10% more technical debt in COTS platforms (Banker </a:t>
+            </a:r>
+            <a:r>
+              <a:rPr lang="en-US" sz="1100" i="1" dirty="0">
+                <a:solidFill>
+                  <a:srgbClr val="2A3F55"/>
+                </a:solidFill>
+                <a:latin typeface="Arial" pitchFamily="34" charset="0"/>
+                <a:ea typeface="Arial" pitchFamily="34" charset="-122"/>
+                <a:cs typeface="Arial" pitchFamily="34" charset="-120"/>
+              </a:rPr>
+              <a:t>et al.</a:t>
+            </a:r>
+            <a:r>
+              <a:rPr lang="en-US" sz="1100" dirty="0">
+                <a:solidFill>
+                  <a:srgbClr val="2A3F55"/>
+                </a:solidFill>
+                <a:latin typeface="Arial" pitchFamily="34" charset="0"/>
+                <a:ea typeface="Arial" pitchFamily="34" charset="-122"/>
+                <a:cs typeface="Arial" pitchFamily="34" charset="-120"/>
+              </a:rPr>
+              <a:t>, 2020)</a:t>
             </a:r>
             <a:endParaRPr lang="en-US" sz="1100" dirty="0"/>
           </a:p>
@@ -7377,8 +7761,8 @@
         </p:nvSpPr>
         <p:spPr>
           <a:xfrm>
-            <a:off x="7040879" y="3218688"/>
-            <a:ext cx="2428435" cy="502920"/>
+            <a:off x="7040880" y="3218688"/>
+            <a:ext cx="2375682" cy="502920"/>
           </a:xfrm>
           <a:prstGeom prst="rect">
             <a:avLst/>
@@ -7429,9 +7813,6 @@
           <a:bodyPr wrap="square" lIns="0" tIns="0" rIns="0" bIns="0" rtlCol="0" anchor="t"/>
           <a:lstStyle/>
           <a:p>
-            <a:pPr marL="0" indent="0">
-              <a:buNone/>
-            </a:pPr>
             <a:r>
               <a:rPr lang="en-US" sz="1100" dirty="0">
                 <a:solidFill>
@@ -7441,7 +7822,29 @@
                 <a:ea typeface="Arial" pitchFamily="34" charset="-122"/>
                 <a:cs typeface="Arial" pitchFamily="34" charset="-120"/>
               </a:rPr>
-              <a:t>higher odds of compromise after one / three months of patch delay (Di Tizio et al., 2023)</a:t>
+              <a:t>higher odds of compromise after one / three months of patch delay (Tizio, Armellini, and </a:t>
+            </a:r>
+            <a:r>
+              <a:rPr lang="en-US" sz="1100" dirty="0" err="1">
+                <a:solidFill>
+                  <a:srgbClr val="2A3F55"/>
+                </a:solidFill>
+                <a:latin typeface="Arial" pitchFamily="34" charset="0"/>
+                <a:ea typeface="Arial" pitchFamily="34" charset="-122"/>
+                <a:cs typeface="Arial" pitchFamily="34" charset="-120"/>
+              </a:rPr>
+              <a:t>Massacci</a:t>
+            </a:r>
+            <a:r>
+              <a:rPr lang="en-US" sz="1100" dirty="0">
+                <a:solidFill>
+                  <a:srgbClr val="2A3F55"/>
+                </a:solidFill>
+                <a:latin typeface="Arial" pitchFamily="34" charset="0"/>
+                <a:ea typeface="Arial" pitchFamily="34" charset="-122"/>
+                <a:cs typeface="Arial" pitchFamily="34" charset="-120"/>
+              </a:rPr>
+              <a:t>, 2023)</a:t>
             </a:r>
             <a:endParaRPr lang="en-US" sz="1100" dirty="0"/>
           </a:p>
@@ -7553,7 +7956,29 @@
                 <a:ea typeface="Arial" pitchFamily="34" charset="-122"/>
                 <a:cs typeface="Arial" pitchFamily="34" charset="-120"/>
               </a:rPr>
-              <a:t>incidents after targeted architectural debt repayment (de Toledo et al., 2021)</a:t>
+              <a:t>incidents after targeted architectural debt repayment (de Toledo </a:t>
+            </a:r>
+            <a:r>
+              <a:rPr lang="en-US" sz="1100" i="1" dirty="0">
+                <a:solidFill>
+                  <a:srgbClr val="2A3F55"/>
+                </a:solidFill>
+                <a:latin typeface="Arial" pitchFamily="34" charset="0"/>
+                <a:ea typeface="Arial" pitchFamily="34" charset="-122"/>
+                <a:cs typeface="Arial" pitchFamily="34" charset="-120"/>
+              </a:rPr>
+              <a:t>et al.</a:t>
+            </a:r>
+            <a:r>
+              <a:rPr lang="en-US" sz="1100" dirty="0">
+                <a:solidFill>
+                  <a:srgbClr val="2A3F55"/>
+                </a:solidFill>
+                <a:latin typeface="Arial" pitchFamily="34" charset="0"/>
+                <a:ea typeface="Arial" pitchFamily="34" charset="-122"/>
+                <a:cs typeface="Arial" pitchFamily="34" charset="-120"/>
+              </a:rPr>
+              <a:t>, 2021)</a:t>
             </a:r>
             <a:endParaRPr lang="en-US" sz="1100" dirty="0"/>
           </a:p>
@@ -7567,8 +7992,8 @@
         </p:nvSpPr>
         <p:spPr>
           <a:xfrm>
-            <a:off x="685800" y="5806440"/>
-            <a:ext cx="5760720" cy="713232"/>
+            <a:off x="685799" y="5806440"/>
+            <a:ext cx="10789919" cy="713232"/>
           </a:xfrm>
           <a:prstGeom prst="rect">
             <a:avLst/>
@@ -7634,7 +8059,7 @@
         <p:spPr>
           <a:xfrm>
             <a:off x="886968" y="6080760"/>
-            <a:ext cx="5394960" cy="384048"/>
+            <a:ext cx="10360152" cy="384048"/>
           </a:xfrm>
           <a:prstGeom prst="rect">
             <a:avLst/>
@@ -7811,7 +8236,29 @@
                 <a:ea typeface="Arial" pitchFamily="34" charset="-122"/>
                 <a:cs typeface="Arial" pitchFamily="34" charset="-120"/>
               </a:rPr>
-              <a:t>Across 44 primary studies on TD prioritisation, quantitative multi-criteria approaches are uncommon and industrial validation is rare (Lenarduzzi et al., 2021). </a:t>
+              <a:t>Across 44 primary studies on TD prioritisation, quantitative multi-criteria approaches are uncommon and industrial validation is rare (Lenarduzzi </a:t>
+            </a:r>
+            <a:r>
+              <a:rPr lang="en-US" sz="1500" i="1" dirty="0">
+                <a:solidFill>
+                  <a:srgbClr val="14283C"/>
+                </a:solidFill>
+                <a:latin typeface="Arial" pitchFamily="34" charset="0"/>
+                <a:ea typeface="Arial" pitchFamily="34" charset="-122"/>
+                <a:cs typeface="Arial" pitchFamily="34" charset="-120"/>
+              </a:rPr>
+              <a:t>et al.</a:t>
+            </a:r>
+            <a:r>
+              <a:rPr lang="en-US" sz="1500" dirty="0">
+                <a:solidFill>
+                  <a:srgbClr val="14283C"/>
+                </a:solidFill>
+                <a:latin typeface="Arial" pitchFamily="34" charset="0"/>
+                <a:ea typeface="Arial" pitchFamily="34" charset="-122"/>
+                <a:cs typeface="Arial" pitchFamily="34" charset="-120"/>
+              </a:rPr>
+              <a:t>, 2021). </a:t>
             </a:r>
             <a:r>
               <a:rPr lang="en-US" sz="1500" b="1" dirty="0">
@@ -7930,7 +8377,7 @@
               <a:buNone/>
             </a:pPr>
             <a:r>
-              <a:rPr lang="en-US" sz="1450" dirty="0">
+              <a:rPr lang="en-US" sz="1400" dirty="0">
                 <a:solidFill>
                   <a:srgbClr val="14283C"/>
                 </a:solidFill>
@@ -7940,7 +8387,7 @@
               </a:rPr>
               <a:t>How can technical debt in mission-critical trading systems be prioritised quantitatively at the service level using operational data?</a:t>
             </a:r>
-            <a:endParaRPr lang="en-US" sz="1450" dirty="0"/>
+            <a:endParaRPr lang="en-US" sz="1400" dirty="0"/>
           </a:p>
         </p:txBody>
       </p:sp>
@@ -8035,7 +8482,7 @@
               <a:buNone/>
             </a:pPr>
             <a:r>
-              <a:rPr lang="en-US" sz="1450" dirty="0">
+              <a:rPr lang="en-US" sz="1400" dirty="0">
                 <a:solidFill>
                   <a:srgbClr val="14283C"/>
                 </a:solidFill>
@@ -8045,7 +8492,7 @@
               </a:rPr>
               <a:t>To what extent do operational service management metrics serve as valid proxies for technical debt severity?</a:t>
             </a:r>
-            <a:endParaRPr lang="en-US" sz="1450" dirty="0"/>
+            <a:endParaRPr lang="en-US" sz="1400" dirty="0"/>
           </a:p>
         </p:txBody>
       </p:sp>
@@ -8140,7 +8587,7 @@
               <a:buNone/>
             </a:pPr>
             <a:r>
-              <a:rPr lang="en-US" sz="1450" dirty="0">
+              <a:rPr lang="en-US" sz="1400" dirty="0">
                 <a:solidFill>
                   <a:srgbClr val="14283C"/>
                 </a:solidFill>
@@ -8150,7 +8597,7 @@
               </a:rPr>
               <a:t>How stable are the resulting rankings when criterion weights are perturbed?</a:t>
             </a:r>
-            <a:endParaRPr lang="en-US" sz="1450" dirty="0"/>
+            <a:endParaRPr lang="en-US" sz="1400" dirty="0"/>
           </a:p>
         </p:txBody>
       </p:sp>
@@ -8290,7 +8737,7 @@
               <a:buNone/>
             </a:pPr>
             <a:r>
-              <a:rPr lang="en-US" sz="1350" dirty="0">
+              <a:rPr lang="en-US" sz="1500" dirty="0">
                 <a:solidFill>
                   <a:srgbClr val="2A3F55"/>
                 </a:solidFill>
@@ -8298,9 +8745,31 @@
                 <a:ea typeface="Arial" pitchFamily="34" charset="-122"/>
                 <a:cs typeface="Arial" pitchFamily="34" charset="-120"/>
               </a:rPr>
-              <a:t>DSR (Hevner et al., 2004) · single-organisation embedded case study · unit of analysis: the IT service as a configuration item</a:t>
-            </a:r>
-            <a:endParaRPr lang="en-US" sz="1350" dirty="0"/>
+              <a:t>DSR (Hevner </a:t>
+            </a:r>
+            <a:r>
+              <a:rPr lang="en-US" sz="1500" i="1" dirty="0">
+                <a:solidFill>
+                  <a:srgbClr val="2A3F55"/>
+                </a:solidFill>
+                <a:latin typeface="Arial" pitchFamily="34" charset="0"/>
+                <a:ea typeface="Arial" pitchFamily="34" charset="-122"/>
+                <a:cs typeface="Arial" pitchFamily="34" charset="-120"/>
+              </a:rPr>
+              <a:t>et al.</a:t>
+            </a:r>
+            <a:r>
+              <a:rPr lang="en-US" sz="1500" dirty="0">
+                <a:solidFill>
+                  <a:srgbClr val="2A3F55"/>
+                </a:solidFill>
+                <a:latin typeface="Arial" pitchFamily="34" charset="0"/>
+                <a:ea typeface="Arial" pitchFamily="34" charset="-122"/>
+                <a:cs typeface="Arial" pitchFamily="34" charset="-120"/>
+              </a:rPr>
+              <a:t>, 2004) · single-organisation embedded case study · unit of analysis: the IT service as a configuration item</a:t>
+            </a:r>
+            <a:endParaRPr lang="en-US" sz="1500" dirty="0"/>
           </a:p>
         </p:txBody>
       </p:sp>
@@ -9665,7 +10134,7 @@
               <a:buNone/>
             </a:pPr>
             <a:r>
-              <a:rPr lang="en-US" sz="1350" dirty="0">
+              <a:rPr lang="en-US" sz="1500" dirty="0">
                 <a:solidFill>
                   <a:srgbClr val="14283C"/>
                 </a:solidFill>
@@ -9675,7 +10144,7 @@
               </a:rPr>
               <a:t>Extract indicators from live ITSM / CMDB records</a:t>
             </a:r>
-            <a:endParaRPr lang="en-US" sz="1350" dirty="0"/>
+            <a:endParaRPr lang="en-US" sz="1500" dirty="0"/>
           </a:p>
         </p:txBody>
       </p:sp>
@@ -9770,7 +10239,7 @@
               <a:buNone/>
             </a:pPr>
             <a:r>
-              <a:rPr lang="en-US" sz="1350" dirty="0">
+              <a:rPr lang="en-US" sz="1500" dirty="0">
                 <a:solidFill>
                   <a:srgbClr val="14283C"/>
                 </a:solidFill>
@@ -9780,7 +10249,7 @@
               </a:rPr>
               <a:t>Vector normalisation (preserves extreme observations)</a:t>
             </a:r>
-            <a:endParaRPr lang="en-US" sz="1350" dirty="0"/>
+            <a:endParaRPr lang="en-US" sz="1500" dirty="0"/>
           </a:p>
         </p:txBody>
       </p:sp>
@@ -9875,7 +10344,7 @@
               <a:buNone/>
             </a:pPr>
             <a:r>
-              <a:rPr lang="en-US" sz="1350" dirty="0">
+              <a:rPr lang="en-US" sz="1500" dirty="0">
                 <a:solidFill>
                   <a:srgbClr val="14283C"/>
                 </a:solidFill>
@@ -9885,7 +10354,7 @@
               </a:rPr>
               <a:t>Weighting: equal (0.20 each) and differential (0.30 MTTR &amp; patch recency)</a:t>
             </a:r>
-            <a:endParaRPr lang="en-US" sz="1350" dirty="0"/>
+            <a:endParaRPr lang="en-US" sz="1500" dirty="0"/>
           </a:p>
         </p:txBody>
       </p:sp>
@@ -9980,7 +10449,7 @@
               <a:buNone/>
             </a:pPr>
             <a:r>
-              <a:rPr lang="en-US" sz="1350" dirty="0">
+              <a:rPr lang="en-US" sz="1500" dirty="0">
                 <a:solidFill>
                   <a:srgbClr val="14283C"/>
                 </a:solidFill>
@@ -9990,7 +10459,7 @@
               </a:rPr>
               <a:t>TOPSIS closeness coefficient Ci ∈ [0, 1]</a:t>
             </a:r>
-            <a:endParaRPr lang="en-US" sz="1350" dirty="0"/>
+            <a:endParaRPr lang="en-US" sz="1500" dirty="0"/>
           </a:p>
         </p:txBody>
       </p:sp>
@@ -10085,7 +10554,7 @@
               <a:buNone/>
             </a:pPr>
             <a:r>
-              <a:rPr lang="en-US" sz="1350" dirty="0">
+              <a:rPr lang="en-US" sz="1500" dirty="0">
                 <a:solidFill>
                   <a:srgbClr val="14283C"/>
                 </a:solidFill>
@@ -10095,7 +10564,7 @@
               </a:rPr>
               <a:t>Rank: lowest Ci = highest debt priority</a:t>
             </a:r>
-            <a:endParaRPr lang="en-US" sz="1350" dirty="0"/>
+            <a:endParaRPr lang="en-US" sz="1500" dirty="0"/>
           </a:p>
         </p:txBody>
       </p:sp>
@@ -10170,7 +10639,7 @@
               <a:buChar char="•"/>
             </a:pPr>
             <a:r>
-              <a:rPr lang="en-US" sz="1350" dirty="0">
+              <a:rPr lang="en-US" sz="1500" dirty="0">
                 <a:solidFill>
                   <a:srgbClr val="14283C"/>
                 </a:solidFill>
@@ -10180,7 +10649,7 @@
               </a:rPr>
               <a:t>Handles mixed cost/benefit criteria and different scales in one procedure</a:t>
             </a:r>
-            <a:endParaRPr lang="en-US" sz="1350" dirty="0"/>
+            <a:endParaRPr lang="en-US" sz="1500" dirty="0"/>
           </a:p>
           <a:p>
             <a:pPr marL="177800" indent="-177800">
@@ -10194,7 +10663,7 @@
               <a:buChar char="•"/>
             </a:pPr>
             <a:r>
-              <a:rPr lang="en-US" sz="1350" dirty="0">
+              <a:rPr lang="en-US" sz="1500" dirty="0">
                 <a:solidFill>
                   <a:srgbClr val="14283C"/>
                 </a:solidFill>
@@ -10204,7 +10673,7 @@
               </a:rPr>
               <a:t>Produces a full ranking, unlike VIKOR's compromise set or AHP alone</a:t>
             </a:r>
-            <a:endParaRPr lang="en-US" sz="1350" dirty="0"/>
+            <a:endParaRPr lang="en-US" sz="1500" dirty="0"/>
           </a:p>
           <a:p>
             <a:pPr marL="177800" indent="-177800">
@@ -10218,7 +10687,7 @@
               <a:buChar char="•"/>
             </a:pPr>
             <a:r>
-              <a:rPr lang="en-US" sz="1350" dirty="0">
+              <a:rPr lang="en-US" sz="1500" dirty="0">
                 <a:solidFill>
                   <a:srgbClr val="14283C"/>
                 </a:solidFill>
@@ -10226,9 +10695,53 @@
                 <a:ea typeface="Arial" pitchFamily="34" charset="-122"/>
                 <a:cs typeface="Arial" pitchFamily="34" charset="-120"/>
               </a:rPr>
-              <a:t>Precedent: Albarak &amp; Bahsoon (2022) for TD, but on controlled data</a:t>
-            </a:r>
-            <a:endParaRPr lang="en-US" sz="1350" dirty="0"/>
+              <a:t>Precedent: </a:t>
+            </a:r>
+            <a:r>
+              <a:rPr lang="en-US" sz="1500" dirty="0" err="1">
+                <a:solidFill>
+                  <a:srgbClr val="14283C"/>
+                </a:solidFill>
+                <a:latin typeface="Arial" pitchFamily="34" charset="0"/>
+                <a:ea typeface="Arial" pitchFamily="34" charset="-122"/>
+                <a:cs typeface="Arial" pitchFamily="34" charset="-120"/>
+              </a:rPr>
+              <a:t>Albarak</a:t>
+            </a:r>
+            <a:r>
+              <a:rPr lang="en-US" sz="1500" dirty="0">
+                <a:solidFill>
+                  <a:srgbClr val="14283C"/>
+                </a:solidFill>
+                <a:latin typeface="Arial" pitchFamily="34" charset="0"/>
+                <a:ea typeface="Arial" pitchFamily="34" charset="-122"/>
+                <a:cs typeface="Arial" pitchFamily="34" charset="-120"/>
+              </a:rPr>
+              <a:t> </a:t>
+            </a:r>
+            <a:r>
+              <a:rPr lang="en-US" sz="1500" i="1" dirty="0">
+                <a:solidFill>
+                  <a:srgbClr val="14283C"/>
+                </a:solidFill>
+                <a:latin typeface="Arial" pitchFamily="34" charset="0"/>
+                <a:ea typeface="Arial" pitchFamily="34" charset="-122"/>
+                <a:cs typeface="Arial" pitchFamily="34" charset="-120"/>
+              </a:rPr>
+              <a:t>et al.</a:t>
+            </a:r>
+            <a:r>
+              <a:rPr lang="en-US" sz="1500" dirty="0">
+                <a:solidFill>
+                  <a:srgbClr val="14283C"/>
+                </a:solidFill>
+                <a:latin typeface="Arial" pitchFamily="34" charset="0"/>
+                <a:ea typeface="Arial" pitchFamily="34" charset="-122"/>
+                <a:cs typeface="Arial" pitchFamily="34" charset="-120"/>
+              </a:rPr>
+              <a:t> (2022) for TD, but on controlled data</a:t>
+            </a:r>
+            <a:endParaRPr lang="en-US" sz="1500" dirty="0"/>
           </a:p>
           <a:p>
             <a:pPr marL="177800" indent="-177800">
@@ -10242,7 +10755,7 @@
               <a:buChar char="•"/>
             </a:pPr>
             <a:r>
-              <a:rPr lang="en-US" sz="1350" b="1" dirty="0">
+              <a:rPr lang="en-US" sz="1500" b="1" dirty="0">
                 <a:solidFill>
                   <a:srgbClr val="14283C"/>
                 </a:solidFill>
@@ -10252,7 +10765,7 @@
               </a:rPr>
               <a:t>Method choice treated as a robustness question, tested against SAW and VIKOR</a:t>
             </a:r>
-            <a:endParaRPr lang="en-US" sz="1350" dirty="0"/>
+            <a:endParaRPr lang="en-US" sz="1500" dirty="0"/>
           </a:p>
         </p:txBody>
       </p:sp>
@@ -10543,7 +11056,7 @@
               <a:buChar char="•"/>
             </a:pPr>
             <a:r>
-              <a:rPr lang="en-US" sz="1350" dirty="0">
+              <a:rPr lang="en-US" sz="1500" dirty="0">
                 <a:solidFill>
                   <a:srgbClr val="14283C"/>
                 </a:solidFill>
@@ -10553,7 +11066,7 @@
               </a:rPr>
               <a:t>Portfolio of 108 services; 53 small vendor GUIs excluded; 6 selected for demonstration on data completeness over the full window</a:t>
             </a:r>
-            <a:endParaRPr lang="en-US" sz="1350" dirty="0"/>
+            <a:endParaRPr lang="en-US" sz="1500" dirty="0"/>
           </a:p>
           <a:p>
             <a:pPr marL="177800" indent="-177800">
@@ -10567,7 +11080,7 @@
               <a:buChar char="•"/>
             </a:pPr>
             <a:r>
-              <a:rPr lang="en-US" sz="1350" dirty="0">
+              <a:rPr lang="en-US" sz="1500" dirty="0">
                 <a:solidFill>
                   <a:srgbClr val="14283C"/>
                 </a:solidFill>
@@ -10577,7 +11090,7 @@
               </a:rPr>
               <a:t>Jan 2024 – Dec 2025, production records only, anonymised at source</a:t>
             </a:r>
-            <a:endParaRPr lang="en-US" sz="1350" dirty="0"/>
+            <a:endParaRPr lang="en-US" sz="1500" dirty="0"/>
           </a:p>
           <a:p>
             <a:pPr marL="177800" indent="-177800">
@@ -10591,7 +11104,7 @@
               <a:buChar char="•"/>
             </a:pPr>
             <a:r>
-              <a:rPr lang="en-US" sz="1350" dirty="0">
+              <a:rPr lang="en-US" sz="1500" dirty="0">
                 <a:solidFill>
                   <a:srgbClr val="14283C"/>
                 </a:solidFill>
@@ -10601,7 +11114,7 @@
               </a:rPr>
               <a:t>Quality filters: alarm-storm consolidation, &lt;0.1 h auto-closures removed, 98th percentile MTTR cap</a:t>
             </a:r>
-            <a:endParaRPr lang="en-US" sz="1350" dirty="0"/>
+            <a:endParaRPr lang="en-US" sz="1500" dirty="0"/>
           </a:p>
         </p:txBody>
       </p:sp>
@@ -10676,7 +11189,7 @@
               <a:buChar char="•"/>
             </a:pPr>
             <a:r>
-              <a:rPr lang="en-US" sz="1350" dirty="0">
+              <a:rPr lang="en-US" sz="1500" dirty="0">
                 <a:solidFill>
                   <a:srgbClr val="14283C"/>
                 </a:solidFill>
@@ -10686,7 +11199,7 @@
               </a:rPr>
               <a:t>Recording practices vary by team → scores are ordinal signals, not measurements</a:t>
             </a:r>
-            <a:endParaRPr lang="en-US" sz="1350" dirty="0"/>
+            <a:endParaRPr lang="en-US" sz="1500" dirty="0"/>
           </a:p>
           <a:p>
             <a:pPr marL="177800" indent="-177800">
@@ -10700,7 +11213,7 @@
               <a:buChar char="•"/>
             </a:pPr>
             <a:r>
-              <a:rPr lang="en-US" sz="1350" dirty="0">
+              <a:rPr lang="en-US" sz="1500" dirty="0">
                 <a:solidFill>
                   <a:srgbClr val="14283C"/>
                 </a:solidFill>
@@ -10710,7 +11223,7 @@
               </a:rPr>
               <a:t>CFR shares its numerator with incident frequency (bounded by sensitivity analysis)</a:t>
             </a:r>
-            <a:endParaRPr lang="en-US" sz="1350" dirty="0"/>
+            <a:endParaRPr lang="en-US" sz="1500" dirty="0"/>
           </a:p>
           <a:p>
             <a:pPr marL="177800" indent="-177800">
@@ -10724,7 +11237,7 @@
               <a:buChar char="•"/>
             </a:pPr>
             <a:r>
-              <a:rPr lang="en-US" sz="1350" dirty="0">
+              <a:rPr lang="en-US" sz="1500" dirty="0">
                 <a:solidFill>
                   <a:srgbClr val="14283C"/>
                 </a:solidFill>
@@ -10734,7 +11247,7 @@
               </a:rPr>
               <a:t>Demonstration set, not a portfolio ranking; the contribution is the instrument and its evaluation logic</a:t>
             </a:r>
-            <a:endParaRPr lang="en-US" sz="1350" dirty="0"/>
+            <a:endParaRPr lang="en-US" sz="1500" dirty="0"/>
           </a:p>
         </p:txBody>
       </p:sp>
@@ -11798,7 +12311,7 @@
               <a:buNone/>
             </a:pPr>
             <a:r>
-              <a:rPr lang="en-US" sz="1250" b="1" dirty="0">
+              <a:rPr lang="en-US" sz="1400" b="1" dirty="0">
                 <a:solidFill>
                   <a:srgbClr val="D98E1F"/>
                 </a:solidFill>
@@ -11808,7 +12321,7 @@
               </a:rPr>
               <a:t>SVC-01 · rank 1</a:t>
             </a:r>
-            <a:endParaRPr lang="en-US" sz="1250" dirty="0"/>
+            <a:endParaRPr lang="en-US" sz="1400" dirty="0"/>
           </a:p>
         </p:txBody>
       </p:sp>
@@ -11837,7 +12350,7 @@
               <a:buNone/>
             </a:pPr>
             <a:r>
-              <a:rPr lang="en-US" sz="1100" dirty="0">
+              <a:rPr lang="en-US" sz="1400" dirty="0">
                 <a:solidFill>
                   <a:srgbClr val="2A3F55"/>
                 </a:solidFill>
@@ -11847,7 +12360,7 @@
               </a:rPr>
               <a:t>Only 64 incidents/yr, but 4,210 unsupported component months and patch recency 63.2 → the debt an incident count cannot see</a:t>
             </a:r>
-            <a:endParaRPr lang="en-US" sz="1100" dirty="0"/>
+            <a:endParaRPr lang="en-US" sz="1400" dirty="0"/>
           </a:p>
         </p:txBody>
       </p:sp>
@@ -11903,7 +12416,7 @@
               <a:buNone/>
             </a:pPr>
             <a:r>
-              <a:rPr lang="en-US" sz="1250" b="1" dirty="0">
+              <a:rPr lang="en-US" sz="1400" b="1" dirty="0">
                 <a:solidFill>
                   <a:srgbClr val="14283C"/>
                 </a:solidFill>
@@ -11913,7 +12426,7 @@
               </a:rPr>
               <a:t>SVC-04 · rank 2</a:t>
             </a:r>
-            <a:endParaRPr lang="en-US" sz="1250" dirty="0"/>
+            <a:endParaRPr lang="en-US" sz="1400" dirty="0"/>
           </a:p>
         </p:txBody>
       </p:sp>
@@ -11942,7 +12455,7 @@
               <a:buNone/>
             </a:pPr>
             <a:r>
-              <a:rPr lang="en-US" sz="1100" dirty="0">
+              <a:rPr lang="en-US" sz="1400" dirty="0">
                 <a:solidFill>
                   <a:srgbClr val="2A3F55"/>
                 </a:solidFill>
@@ -11952,7 +12465,7 @@
               </a:rPr>
               <a:t>574 incidents/yr, MTTR 41.9 h, CFR 3.38, yet a clean lifecycle record → architectural &amp; process debt</a:t>
             </a:r>
-            <a:endParaRPr lang="en-US" sz="1100" dirty="0"/>
+            <a:endParaRPr lang="en-US" sz="1400" dirty="0"/>
           </a:p>
         </p:txBody>
       </p:sp>
@@ -12008,7 +12521,7 @@
               <a:buNone/>
             </a:pPr>
             <a:r>
-              <a:rPr lang="en-US" sz="1250" b="1" dirty="0">
+              <a:rPr lang="en-US" sz="1400" b="1" dirty="0">
                 <a:solidFill>
                   <a:srgbClr val="14283C"/>
                 </a:solidFill>
@@ -12018,7 +12531,7 @@
               </a:rPr>
               <a:t>SVC-03 · rank 6</a:t>
             </a:r>
-            <a:endParaRPr lang="en-US" sz="1250" dirty="0"/>
+            <a:endParaRPr lang="en-US" sz="1400" dirty="0"/>
           </a:p>
         </p:txBody>
       </p:sp>
@@ -12047,7 +12560,7 @@
               <a:buNone/>
             </a:pPr>
             <a:r>
-              <a:rPr lang="en-US" sz="1100" dirty="0">
+              <a:rPr lang="en-US" sz="1400" dirty="0">
                 <a:solidFill>
                   <a:srgbClr val="2A3F55"/>
                 </a:solidFill>
@@ -12057,7 +12570,7 @@
               </a:rPr>
               <a:t>The portfolio's reference for a well-maintained service</a:t>
             </a:r>
-            <a:endParaRPr lang="en-US" sz="1100" dirty="0"/>
+            <a:endParaRPr lang="en-US" sz="1400" dirty="0"/>
           </a:p>
         </p:txBody>
       </p:sp>
@@ -12375,7 +12888,7 @@
               <a:buNone/>
             </a:pPr>
             <a:r>
-              <a:rPr lang="en-US" sz="1100" dirty="0">
+              <a:rPr lang="en-US" sz="1400" dirty="0">
                 <a:solidFill>
                   <a:srgbClr val="2A3F55"/>
                 </a:solidFill>
@@ -12385,7 +12898,7 @@
               </a:rPr>
               <a:t>Weight &amp; temporal variation, Kendall's τ, exact p over 720 permutations</a:t>
             </a:r>
-            <a:endParaRPr lang="en-US" sz="1100" dirty="0"/>
+            <a:endParaRPr lang="en-US" sz="1400" dirty="0"/>
           </a:p>
         </p:txBody>
       </p:sp>
@@ -12414,7 +12927,7 @@
               <a:buNone/>
             </a:pPr>
             <a:r>
-              <a:rPr lang="en-US" sz="1200" b="1" dirty="0">
+              <a:rPr lang="en-US" sz="1400" b="1" dirty="0">
                 <a:solidFill>
                   <a:srgbClr val="1E7F82"/>
                 </a:solidFill>
@@ -12424,7 +12937,7 @@
               </a:rPr>
               <a:t>τ = 0.60–1.00</a:t>
             </a:r>
-            <a:endParaRPr lang="en-US" sz="1200" dirty="0"/>
+            <a:endParaRPr lang="en-US" sz="1400" dirty="0"/>
           </a:p>
         </p:txBody>
       </p:sp>
@@ -12526,7 +13039,7 @@
               <a:buNone/>
             </a:pPr>
             <a:r>
-              <a:rPr lang="en-US" sz="1100" dirty="0">
+              <a:rPr lang="en-US" sz="1400" dirty="0">
                 <a:solidFill>
                   <a:srgbClr val="2A3F55"/>
                 </a:solidFill>
@@ -12536,7 +13049,7 @@
               </a:rPr>
               <a:t>20,000 Dirichlet-sampled weightings, rank-acceptability analysis</a:t>
             </a:r>
-            <a:endParaRPr lang="en-US" sz="1100" dirty="0"/>
+            <a:endParaRPr lang="en-US" sz="1400" dirty="0"/>
           </a:p>
         </p:txBody>
       </p:sp>
@@ -12565,7 +13078,7 @@
               <a:buNone/>
             </a:pPr>
             <a:r>
-              <a:rPr lang="en-US" sz="1200" b="1" dirty="0">
+              <a:rPr lang="en-US" sz="1400" b="1" dirty="0">
                 <a:solidFill>
                   <a:srgbClr val="1E7F82"/>
                 </a:solidFill>
@@ -12575,7 +13088,7 @@
               </a:rPr>
               <a:t>extremes robust</a:t>
             </a:r>
-            <a:endParaRPr lang="en-US" sz="1200" dirty="0"/>
+            <a:endParaRPr lang="en-US" sz="1400" dirty="0"/>
           </a:p>
         </p:txBody>
       </p:sp>
@@ -12677,7 +13190,7 @@
               <a:buNone/>
             </a:pPr>
             <a:r>
-              <a:rPr lang="en-US" sz="1100" dirty="0">
+              <a:rPr lang="en-US" sz="1400" dirty="0">
                 <a:solidFill>
                   <a:srgbClr val="2A3F55"/>
                 </a:solidFill>
@@ -12687,7 +13200,7 @@
               </a:rPr>
               <a:t>Re-ranked with SAW &amp; VIKOR</a:t>
             </a:r>
-            <a:endParaRPr lang="en-US" sz="1100" dirty="0"/>
+            <a:endParaRPr lang="en-US" sz="1400" dirty="0"/>
           </a:p>
         </p:txBody>
       </p:sp>
@@ -12716,7 +13229,7 @@
               <a:buNone/>
             </a:pPr>
             <a:r>
-              <a:rPr lang="en-US" sz="1200" b="1" dirty="0">
+              <a:rPr lang="en-US" sz="1400" b="1" dirty="0">
                 <a:solidFill>
                   <a:srgbClr val="1E7F82"/>
                 </a:solidFill>
@@ -12726,7 +13239,7 @@
               </a:rPr>
               <a:t>τ = 0.60–1.00</a:t>
             </a:r>
-            <a:endParaRPr lang="en-US" sz="1200" dirty="0"/>
+            <a:endParaRPr lang="en-US" sz="1400" dirty="0"/>
           </a:p>
         </p:txBody>
       </p:sp>
@@ -12828,7 +13341,7 @@
               <a:buNone/>
             </a:pPr>
             <a:r>
-              <a:rPr lang="en-US" sz="1100" dirty="0">
+              <a:rPr lang="en-US" sz="1400" dirty="0">
                 <a:solidFill>
                   <a:srgbClr val="2A3F55"/>
                 </a:solidFill>
@@ -12838,7 +13351,7 @@
               </a:rPr>
               <a:t>Against an incident-only baseline</a:t>
             </a:r>
-            <a:endParaRPr lang="en-US" sz="1100" dirty="0"/>
+            <a:endParaRPr lang="en-US" sz="1400" dirty="0"/>
           </a:p>
         </p:txBody>
       </p:sp>
@@ -12867,7 +13380,7 @@
               <a:buNone/>
             </a:pPr>
             <a:r>
-              <a:rPr lang="en-US" sz="1200" b="1" dirty="0">
+              <a:rPr lang="en-US" sz="1400" b="1" dirty="0">
                 <a:solidFill>
                   <a:srgbClr val="1E7F82"/>
                 </a:solidFill>
@@ -12877,7 +13390,7 @@
               </a:rPr>
               <a:t>τ = 0.47 / 0.33</a:t>
             </a:r>
-            <a:endParaRPr lang="en-US" sz="1200" dirty="0"/>
+            <a:endParaRPr lang="en-US" sz="1400" dirty="0"/>
           </a:p>
         </p:txBody>
       </p:sp>
@@ -12979,7 +13492,7 @@
               <a:buNone/>
             </a:pPr>
             <a:r>
-              <a:rPr lang="en-US" sz="1100" dirty="0">
+              <a:rPr lang="en-US" sz="1400" dirty="0">
                 <a:solidFill>
                   <a:srgbClr val="2A3F55"/>
                 </a:solidFill>
@@ -12989,7 +13502,7 @@
               </a:rPr>
               <a:t>Leave-one-out rank reversal; absolute-mode variant</a:t>
             </a:r>
-            <a:endParaRPr lang="en-US" sz="1100" dirty="0"/>
+            <a:endParaRPr lang="en-US" sz="1400" dirty="0"/>
           </a:p>
         </p:txBody>
       </p:sp>
@@ -13018,7 +13531,7 @@
               <a:buNone/>
             </a:pPr>
             <a:r>
-              <a:rPr lang="en-US" sz="1200" b="1" dirty="0">
+              <a:rPr lang="en-US" sz="1400" b="1" dirty="0">
                 <a:solidFill>
                   <a:srgbClr val="D98E1F"/>
                 </a:solidFill>
@@ -13028,7 +13541,7 @@
               </a:rPr>
               <a:t>reversal-free by construction</a:t>
             </a:r>
-            <a:endParaRPr lang="en-US" sz="1200" dirty="0"/>
+            <a:endParaRPr lang="en-US" sz="1400" dirty="0"/>
           </a:p>
         </p:txBody>
       </p:sp>
@@ -13319,7 +13832,7 @@
               <a:buChar char="•"/>
             </a:pPr>
             <a:r>
-              <a:rPr lang="en-US" sz="1350" dirty="0">
+              <a:rPr lang="en-US" sz="1500" dirty="0">
                 <a:solidFill>
                   <a:srgbClr val="14283C"/>
                 </a:solidFill>
@@ -13329,7 +13842,7 @@
               </a:rPr>
               <a:t>Weight sensitivity 2025: τ = 1.000 (identical order)</a:t>
             </a:r>
-            <a:endParaRPr lang="en-US" sz="1350" dirty="0"/>
+            <a:endParaRPr lang="en-US" sz="1500" dirty="0"/>
           </a:p>
           <a:p>
             <a:pPr marL="177800" indent="-177800">
@@ -13343,7 +13856,7 @@
               <a:buChar char="•"/>
             </a:pPr>
             <a:r>
-              <a:rPr lang="en-US" sz="1350" dirty="0">
+              <a:rPr lang="en-US" sz="1500" dirty="0">
                 <a:solidFill>
                   <a:srgbClr val="14283C"/>
                 </a:solidFill>
@@ -13353,7 +13866,7 @@
               </a:rPr>
               <a:t>Weight sensitivity 2024: τ = 0.867 (one swap at the top)</a:t>
             </a:r>
-            <a:endParaRPr lang="en-US" sz="1350" dirty="0"/>
+            <a:endParaRPr lang="en-US" sz="1500" dirty="0"/>
           </a:p>
           <a:p>
             <a:pPr marL="177800" indent="-177800">
@@ -13367,7 +13880,7 @@
               <a:buChar char="•"/>
             </a:pPr>
             <a:r>
-              <a:rPr lang="en-US" sz="1350" dirty="0">
+              <a:rPr lang="en-US" sz="1500" dirty="0">
                 <a:solidFill>
                   <a:srgbClr val="14283C"/>
                 </a:solidFill>
@@ -13377,7 +13890,7 @@
               </a:rPr>
               <a:t>Temporal 2025 vs 2024: τ = 0.600 / 0.733, tracking real profile change, above all SVC-06's broad deterioration</a:t>
             </a:r>
-            <a:endParaRPr lang="en-US" sz="1350" dirty="0"/>
+            <a:endParaRPr lang="en-US" sz="1500" dirty="0"/>
           </a:p>
           <a:p>
             <a:pPr marL="177800" indent="-177800">
@@ -13391,7 +13904,7 @@
               <a:buChar char="•"/>
             </a:pPr>
             <a:r>
-              <a:rPr lang="en-US" sz="1350" b="1" dirty="0">
+              <a:rPr lang="en-US" sz="1500" b="1" dirty="0">
                 <a:solidFill>
                   <a:srgbClr val="14283C"/>
                 </a:solidFill>
@@ -13401,7 +13914,7 @@
               </a:rPr>
               <a:t>The lowest-priority position is identical in every run</a:t>
             </a:r>
-            <a:endParaRPr lang="en-US" sz="1350" dirty="0"/>
+            <a:endParaRPr lang="en-US" sz="1500" dirty="0"/>
           </a:p>
         </p:txBody>
       </p:sp>
@@ -13464,7 +13977,7 @@
               <a:buNone/>
             </a:pPr>
             <a:r>
-              <a:rPr lang="en-US" sz="1100" b="1" kern="0" spc="200" dirty="0">
+              <a:rPr lang="en-US" sz="1400" b="1" kern="0" spc="200" dirty="0">
                 <a:solidFill>
                   <a:srgbClr val="5C7186"/>
                 </a:solidFill>
@@ -13474,7 +13987,7 @@
               </a:rPr>
               <a:t>FULL WEIGHT SPACE · 20,000 DRAWS</a:t>
             </a:r>
-            <a:endParaRPr lang="en-US" sz="1100" dirty="0"/>
+            <a:endParaRPr lang="en-US" sz="1400" dirty="0"/>
           </a:p>
         </p:txBody>
       </p:sp>
@@ -13545,7 +14058,7 @@
               <a:buNone/>
             </a:pPr>
             <a:r>
-              <a:rPr lang="en-US" sz="1250" dirty="0">
+              <a:rPr lang="en-US" sz="1400" dirty="0">
                 <a:solidFill>
                   <a:srgbClr val="2A3F55"/>
                 </a:solidFill>
@@ -13555,7 +14068,7 @@
               </a:rPr>
               <a:t>of all admissible weightings place SVC-03 last, and rank 1 falls to SVC-01, SVC-06 or SVC-04 in every single draw (41%, 32%, 27%). The bottom is weight-independent; the single top rank is a property of the cluster.</a:t>
             </a:r>
-            <a:endParaRPr lang="en-US" sz="1250" dirty="0"/>
+            <a:endParaRPr lang="en-US" sz="1400" dirty="0"/>
           </a:p>
         </p:txBody>
       </p:sp>

</xml_diff>